<commit_message>
Proposal deck: new-buyer column on segments, G1 and G2 with formulas and worked examples
Co-Authored-By: Claude Opus 5.5 <noreply@anthropic.com>
Claude-Session: https://claude.ai/code/session_01XiLXGU1oR1hNbNccyNpRo1
</commit_message>
<xml_diff>
--- a/proposal/DemandAI_Pilot_Proposal.pptx
+++ b/proposal/DemandAI_Pilot_Proposal.pptx
@@ -139,14 +139,14 @@
   <p:extLst>
     <p:ext uri="{521415D9-36F7-43E2-AB2F-B90AF26B5E84}">
       <p14:sectionLst xmlns:p14="http://schemas.microsoft.com/office/powerpoint/2010/main">
-        <p14:section name="Overview" id="{d0dfdf54-941a-7d83-b245-018a2341065a}">
+        <p14:section name="Overview" id="{75a1abb7-3597-320a-e5ea-f9bff3da0b73}">
           <p14:sldIdLst>
             <p14:sldId id="256"/>
             <p14:sldId id="257"/>
             <p14:sldId id="258"/>
           </p14:sldIdLst>
         </p14:section>
-        <p14:section name="Understanding" id="{10c90d0c-b070-cddf-79d8-2b4546988b0f}">
+        <p14:section name="Understanding" id="{83c87586-cf7c-5399-3cc5-e781f24f4632}">
           <p14:sldIdLst>
             <p14:sldId id="259"/>
             <p14:sldId id="260"/>
@@ -163,27 +163,27 @@
             <p14:sldId id="271"/>
           </p14:sldIdLst>
         </p14:section>
-        <p14:section name="Key inputs" id="{13ba5693-f062-fc5e-ac3f-f806cfbf9d98}">
+        <p14:section name="Key inputs" id="{d9aad8b0-db91-e52f-2f8c-13606280acd4}">
           <p14:sldIdLst>
             <p14:sldId id="272"/>
             <p14:sldId id="273"/>
             <p14:sldId id="274"/>
           </p14:sldIdLst>
         </p14:section>
-        <p14:section name="Success criteria" id="{b86da8d8-0016-a1c5-e58c-c276a6b6c0e7}">
+        <p14:section name="Success criteria" id="{6ba15865-33b1-fcdc-a96b-d9a83f7fb4bf}">
           <p14:sldIdLst>
             <p14:sldId id="275"/>
             <p14:sldId id="276"/>
             <p14:sldId id="277"/>
           </p14:sldIdLst>
         </p14:section>
-        <p14:section name="Timeline" id="{6953b9bf-678b-a241-b21d-ed30f198e823}">
+        <p14:section name="Timeline" id="{39140a6e-9b4b-e1bb-d910-42eb2e5dad73}">
           <p14:sldIdLst>
             <p14:sldId id="278"/>
             <p14:sldId id="279"/>
           </p14:sldIdLst>
         </p14:section>
-        <p14:section name="Appendix" id="{174a5e38-6680-4099-3846-84ac50a0823b}">
+        <p14:section name="Appendix" id="{a5bbc30b-69ca-5bd5-034a-42a3e1397804}">
           <p14:sldIdLst>
             <p14:sldId id="280"/>
             <p14:sldId id="281"/>
@@ -952,7 +952,7 @@
           <a:p>
             <a:r>
               <a:rPr lang="en-US" dirty="0"/>
-              <a:t/>
+              <a:t>The right-hand column is how the play changes for a fresh buyer, an account that is not yet a customer. The content named is the approved content in the Content library: the migration case study, the site assessment one-pager, the plant-expansion case study, the peer story and the webinar recording.</a:t>
             </a:r>
             <a:endParaRPr lang="en-US" dirty="0"/>
           </a:p>
@@ -1656,7 +1656,7 @@
           <a:p>
             <a:r>
               <a:rPr lang="en-US" dirty="0"/>
-              <a:t>G1 asks whether the system saves people time; G2 asks whether people trust what it recommends. Spot-checked items count towards both, so the measures are not only drawn from the items people chose to look at.</a:t>
+              <a:t>G1: the minutes come from how long each For Review decision took, logged automatically. Actions that went ahead on their own take no review minutes, which is where the saving comes from. G2: only first-pass decisions count. Choosing an alternative after a rejection is tracked separately, not as an acceptance.</a:t>
             </a:r>
             <a:endParaRPr lang="en-US" dirty="0"/>
           </a:p>
@@ -8269,12 +8269,13 @@
             <a:tbl>
               <a:tblPr/>
               <a:tblGrid>
-                <a:gridCol w="1600200"/>
-                <a:gridCol w="2240280"/>
-                <a:gridCol w="2834640"/>
-                <a:gridCol w="4416552"/>
+                <a:gridCol w="1325880"/>
+                <a:gridCol w="1691640"/>
+                <a:gridCol w="2194560"/>
+                <a:gridCol w="2971800"/>
+                <a:gridCol w="2907792"/>
               </a:tblGrid>
-              <a:tr h="457200">
+              <a:tr h="566928">
                 <a:tc>
                   <a:txBody>
                     <a:bodyPr/>
@@ -8284,17 +8285,17 @@
                         <a:buNone/>
                       </a:pPr>
                       <a:r>
-                        <a:rPr lang="en-US" sz="1250" b="1" dirty="0">
+                        <a:rPr lang="en-US" sz="1200" b="1" dirty="0">
                           <a:solidFill>
                             <a:schemeClr val="bg1"/>
                           </a:solidFill>
                         </a:rPr>
                         <a:t>Micro-segment</a:t>
                       </a:r>
-                      <a:endParaRPr lang="en-US" sz="1250" dirty="0"/>
+                      <a:endParaRPr lang="en-US" sz="1200" dirty="0"/>
                     </a:p>
                   </a:txBody>
-                  <a:tcPr marL="64008" marR="64008" marT="64008" marB="64008" anchor="ctr">
+                  <a:tcPr marL="54864" marR="54864" marT="54864" marB="54864" anchor="ctr">
                     <a:lnL w="6350" cap="flat" cmpd="sng" algn="ctr">
                       <a:solidFill>
                         <a:srgbClr val="D9DEE5"/>
@@ -8345,17 +8346,17 @@
                         <a:buNone/>
                       </a:pPr>
                       <a:r>
-                        <a:rPr lang="en-US" sz="1250" b="1" dirty="0">
+                        <a:rPr lang="en-US" sz="1200" b="1" dirty="0">
                           <a:solidFill>
                             <a:schemeClr val="bg1"/>
                           </a:solidFill>
                         </a:rPr>
                         <a:t>Signal that triggers it</a:t>
                       </a:r>
-                      <a:endParaRPr lang="en-US" sz="1250" dirty="0"/>
+                      <a:endParaRPr lang="en-US" sz="1200" dirty="0"/>
                     </a:p>
                   </a:txBody>
-                  <a:tcPr marL="64008" marR="64008" marT="64008" marB="64008" anchor="ctr">
+                  <a:tcPr marL="54864" marR="54864" marT="54864" marB="54864" anchor="ctr">
                     <a:lnL w="6350" cap="flat" cmpd="sng" algn="ctr">
                       <a:solidFill>
                         <a:srgbClr val="D9DEE5"/>
@@ -8406,17 +8407,17 @@
                         <a:buNone/>
                       </a:pPr>
                       <a:r>
-                        <a:rPr lang="en-US" sz="1250" b="1" dirty="0">
+                        <a:rPr lang="en-US" sz="1200" b="1" dirty="0">
                           <a:solidFill>
                             <a:schemeClr val="bg1"/>
                           </a:solidFill>
                         </a:rPr>
                         <a:t>Angle (the play)</a:t>
                       </a:r>
-                      <a:endParaRPr lang="en-US" sz="1250" dirty="0"/>
+                      <a:endParaRPr lang="en-US" sz="1200" dirty="0"/>
                     </a:p>
                   </a:txBody>
-                  <a:tcPr marL="64008" marR="64008" marT="64008" marB="64008" anchor="ctr">
+                  <a:tcPr marL="54864" marR="54864" marT="54864" marB="54864" anchor="ctr">
                     <a:lnL w="6350" cap="flat" cmpd="sng" algn="ctr">
                       <a:solidFill>
                         <a:srgbClr val="D9DEE5"/>
@@ -8467,17 +8468,17 @@
                         <a:buNone/>
                       </a:pPr>
                       <a:r>
-                        <a:rPr lang="en-US" sz="1250" b="1" dirty="0">
+                        <a:rPr lang="en-US" sz="1200" b="1" dirty="0">
                           <a:solidFill>
                             <a:schemeClr val="bg1"/>
                           </a:solidFill>
                         </a:rPr>
                         <a:t>Actions your team sets in Setup</a:t>
                       </a:r>
-                      <a:endParaRPr lang="en-US" sz="1250" dirty="0"/>
+                      <a:endParaRPr lang="en-US" sz="1200" dirty="0"/>
                     </a:p>
                   </a:txBody>
-                  <a:tcPr marL="64008" marR="64008" marT="64008" marB="64008" anchor="ctr">
+                  <a:tcPr marL="54864" marR="54864" marT="54864" marB="54864" anchor="ctr">
                     <a:lnL w="6350" cap="flat" cmpd="sng" algn="ctr">
                       <a:solidFill>
                         <a:srgbClr val="D9DEE5"/>
@@ -8519,8 +8520,6 @@
                     </a:solidFill>
                   </a:tcPr>
                 </a:tc>
-              </a:tr>
-              <a:tr h="457200">
                 <a:tc>
                   <a:txBody>
                     <a:bodyPr/>
@@ -8535,12 +8534,75 @@
                             <a:schemeClr val="tx1"/>
                           </a:solidFill>
                         </a:rPr>
-                        <a:t>Inquiry</a:t>
+                        <a:t>For a new buyer (net-new account)</a:t>
                       </a:r>
                       <a:endParaRPr lang="en-US" sz="1200" dirty="0"/>
                     </a:p>
                   </a:txBody>
-                  <a:tcPr marL="64008" marR="64008" marT="64008" marB="64008" anchor="ctr">
+                  <a:tcPr marL="54864" marR="54864" marT="54864" marB="54864" anchor="ctr">
+                    <a:lnL w="6350" cap="flat" cmpd="sng" algn="ctr">
+                      <a:solidFill>
+                        <a:srgbClr val="D9DEE5"/>
+                      </a:solidFill>
+                      <a:prstDash val="solid"/>
+                      <a:round/>
+                      <a:headEnd type="none" w="med" len="med"/>
+                      <a:tailEnd type="none" w="med" len="med"/>
+                    </a:lnL>
+                    <a:lnR w="6350" cap="flat" cmpd="sng" algn="ctr">
+                      <a:solidFill>
+                        <a:srgbClr val="D9DEE5"/>
+                      </a:solidFill>
+                      <a:prstDash val="solid"/>
+                      <a:round/>
+                      <a:headEnd type="none" w="med" len="med"/>
+                      <a:tailEnd type="none" w="med" len="med"/>
+                    </a:lnR>
+                    <a:lnT w="6350" cap="flat" cmpd="sng" algn="ctr">
+                      <a:solidFill>
+                        <a:srgbClr val="D9DEE5"/>
+                      </a:solidFill>
+                      <a:prstDash val="solid"/>
+                      <a:round/>
+                      <a:headEnd type="none" w="med" len="med"/>
+                      <a:tailEnd type="none" w="med" len="med"/>
+                    </a:lnT>
+                    <a:lnB w="6350" cap="flat" cmpd="sng" algn="ctr">
+                      <a:solidFill>
+                        <a:srgbClr val="D9DEE5"/>
+                      </a:solidFill>
+                      <a:prstDash val="solid"/>
+                      <a:round/>
+                      <a:headEnd type="none" w="med" len="med"/>
+                      <a:tailEnd type="none" w="med" len="med"/>
+                    </a:lnB>
+                    <a:solidFill>
+                      <a:schemeClr val="accent1"/>
+                    </a:solidFill>
+                  </a:tcPr>
+                </a:tc>
+              </a:tr>
+              <a:tr h="566928">
+                <a:tc>
+                  <a:txBody>
+                    <a:bodyPr/>
+                    <a:lstStyle/>
+                    <a:p>
+                      <a:pPr indent="0" marL="0">
+                        <a:buNone/>
+                      </a:pPr>
+                      <a:r>
+                        <a:rPr lang="en-US" sz="1100" b="1" dirty="0">
+                          <a:solidFill>
+                            <a:schemeClr val="tx1"/>
+                          </a:solidFill>
+                        </a:rPr>
+                        <a:t>Inquiry</a:t>
+                      </a:r>
+                      <a:endParaRPr lang="en-US" sz="1100" dirty="0"/>
+                    </a:p>
+                  </a:txBody>
+                  <a:tcPr marL="54864" marR="54864" marT="54864" marB="54864" anchor="ctr">
                     <a:lnL w="6350" cap="flat" cmpd="sng" algn="ctr">
                       <a:solidFill>
                         <a:srgbClr val="D9DEE5"/>
@@ -8591,17 +8653,17 @@
                         <a:buNone/>
                       </a:pPr>
                       <a:r>
-                        <a:rPr lang="en-US" sz="1200" dirty="0">
+                        <a:rPr lang="en-US" sz="1100" dirty="0">
                           <a:solidFill>
                             <a:schemeClr val="tx1"/>
                           </a:solidFill>
                         </a:rPr>
                         <a:t>Inquiry or RFQ</a:t>
                       </a:r>
-                      <a:endParaRPr lang="en-US" sz="1200" dirty="0"/>
+                      <a:endParaRPr lang="en-US" sz="1100" dirty="0"/>
                     </a:p>
                   </a:txBody>
-                  <a:tcPr marL="64008" marR="64008" marT="64008" marB="64008" anchor="ctr">
+                  <a:tcPr marL="54864" marR="54864" marT="54864" marB="54864" anchor="ctr">
                     <a:lnL w="6350" cap="flat" cmpd="sng" algn="ctr">
                       <a:solidFill>
                         <a:srgbClr val="D9DEE5"/>
@@ -8652,17 +8714,17 @@
                         <a:buNone/>
                       </a:pPr>
                       <a:r>
-                        <a:rPr lang="en-US" sz="1200" dirty="0">
+                        <a:rPr lang="en-US" sz="1100" dirty="0">
                           <a:solidFill>
                             <a:schemeClr val="tx1"/>
                           </a:solidFill>
                         </a:rPr>
                         <a:t>Answer the question they asked while it is live</a:t>
                       </a:r>
-                      <a:endParaRPr lang="en-US" sz="1200" dirty="0"/>
+                      <a:endParaRPr lang="en-US" sz="1100" dirty="0"/>
                     </a:p>
                   </a:txBody>
-                  <a:tcPr marL="64008" marR="64008" marT="64008" marB="64008" anchor="ctr">
+                  <a:tcPr marL="54864" marR="54864" marT="54864" marB="54864" anchor="ctr">
                     <a:lnL w="6350" cap="flat" cmpd="sng" algn="ctr">
                       <a:solidFill>
                         <a:srgbClr val="D9DEE5"/>
@@ -8713,17 +8775,17 @@
                         <a:buNone/>
                       </a:pPr>
                       <a:r>
-                        <a:rPr lang="en-US" sz="1200" dirty="0">
+                        <a:rPr lang="en-US" sz="1100" dirty="0">
                           <a:solidFill>
                             <a:schemeClr val="tx1"/>
                           </a:solidFill>
                         </a:rPr>
                         <a:t>Call to follow up on the inquiry · Route the inquiry to the sales owner</a:t>
                       </a:r>
-                      <a:endParaRPr lang="en-US" sz="1200" dirty="0"/>
+                      <a:endParaRPr lang="en-US" sz="1100" dirty="0"/>
                     </a:p>
                   </a:txBody>
-                  <a:tcPr marL="64008" marR="64008" marT="64008" marB="64008" anchor="ctr">
+                  <a:tcPr marL="54864" marR="54864" marT="54864" marB="54864" anchor="ctr">
                     <a:lnL w="6350" cap="flat" cmpd="sng" algn="ctr">
                       <a:solidFill>
                         <a:srgbClr val="D9DEE5"/>
@@ -8765,8 +8827,6 @@
                     </a:solidFill>
                   </a:tcPr>
                 </a:tc>
-              </a:tr>
-              <a:tr h="457200">
                 <a:tc>
                   <a:txBody>
                     <a:bodyPr/>
@@ -8776,17 +8836,80 @@
                         <a:buNone/>
                       </a:pPr>
                       <a:r>
-                        <a:rPr lang="en-US" sz="1200" b="1" dirty="0">
+                        <a:rPr lang="en-US" sz="1100" dirty="0">
+                          <a:solidFill>
+                            <a:schemeClr val="tx1"/>
+                          </a:solidFill>
+                        </a:rPr>
+                        <a:t>Same play: answer fast. Share the one-shutdown migration case study; route to the sales owner for their region.</a:t>
+                      </a:r>
+                      <a:endParaRPr lang="en-US" sz="1100" dirty="0"/>
+                    </a:p>
+                  </a:txBody>
+                  <a:tcPr marL="54864" marR="54864" marT="54864" marB="54864" anchor="ctr">
+                    <a:lnL w="6350" cap="flat" cmpd="sng" algn="ctr">
+                      <a:solidFill>
+                        <a:srgbClr val="D9DEE5"/>
+                      </a:solidFill>
+                      <a:prstDash val="solid"/>
+                      <a:round/>
+                      <a:headEnd type="none" w="med" len="med"/>
+                      <a:tailEnd type="none" w="med" len="med"/>
+                    </a:lnL>
+                    <a:lnR w="6350" cap="flat" cmpd="sng" algn="ctr">
+                      <a:solidFill>
+                        <a:srgbClr val="D9DEE5"/>
+                      </a:solidFill>
+                      <a:prstDash val="solid"/>
+                      <a:round/>
+                      <a:headEnd type="none" w="med" len="med"/>
+                      <a:tailEnd type="none" w="med" len="med"/>
+                    </a:lnR>
+                    <a:lnT w="6350" cap="flat" cmpd="sng" algn="ctr">
+                      <a:solidFill>
+                        <a:srgbClr val="D9DEE5"/>
+                      </a:solidFill>
+                      <a:prstDash val="solid"/>
+                      <a:round/>
+                      <a:headEnd type="none" w="med" len="med"/>
+                      <a:tailEnd type="none" w="med" len="med"/>
+                    </a:lnT>
+                    <a:lnB w="6350" cap="flat" cmpd="sng" algn="ctr">
+                      <a:solidFill>
+                        <a:srgbClr val="D9DEE5"/>
+                      </a:solidFill>
+                      <a:prstDash val="solid"/>
+                      <a:round/>
+                      <a:headEnd type="none" w="med" len="med"/>
+                      <a:tailEnd type="none" w="med" len="med"/>
+                    </a:lnB>
+                    <a:solidFill>
+                      <a:schemeClr val="accent5"/>
+                    </a:solidFill>
+                  </a:tcPr>
+                </a:tc>
+              </a:tr>
+              <a:tr h="566928">
+                <a:tc>
+                  <a:txBody>
+                    <a:bodyPr/>
+                    <a:lstStyle/>
+                    <a:p>
+                      <a:pPr indent="0" marL="0">
+                        <a:buNone/>
+                      </a:pPr>
+                      <a:r>
+                        <a:rPr lang="en-US" sz="1100" b="1" dirty="0">
                           <a:solidFill>
                             <a:schemeClr val="tx1"/>
                           </a:solidFill>
                         </a:rPr>
                         <a:t>Modernisation</a:t>
                       </a:r>
-                      <a:endParaRPr lang="en-US" sz="1200" dirty="0"/>
+                      <a:endParaRPr lang="en-US" sz="1100" dirty="0"/>
                     </a:p>
                   </a:txBody>
-                  <a:tcPr marL="64008" marR="64008" marT="64008" marB="64008" anchor="ctr">
+                  <a:tcPr marL="54864" marR="54864" marT="54864" marB="54864" anchor="ctr">
                     <a:lnL w="6350" cap="flat" cmpd="sng" algn="ctr">
                       <a:solidFill>
                         <a:srgbClr val="D9DEE5"/>
@@ -8837,17 +8960,17 @@
                         <a:buNone/>
                       </a:pPr>
                       <a:r>
-                        <a:rPr lang="en-US" sz="1200" dirty="0">
+                        <a:rPr lang="en-US" sz="1100" dirty="0">
                           <a:solidFill>
                             <a:schemeClr val="tx1"/>
                           </a:solidFill>
                         </a:rPr>
                         <a:t>Installed system near end of support</a:t>
                       </a:r>
-                      <a:endParaRPr lang="en-US" sz="1200" dirty="0"/>
+                      <a:endParaRPr lang="en-US" sz="1100" dirty="0"/>
                     </a:p>
                   </a:txBody>
-                  <a:tcPr marL="64008" marR="64008" marT="64008" marB="64008" anchor="ctr">
+                  <a:tcPr marL="54864" marR="54864" marT="54864" marB="54864" anchor="ctr">
                     <a:lnL w="6350" cap="flat" cmpd="sng" algn="ctr">
                       <a:solidFill>
                         <a:srgbClr val="D9DEE5"/>
@@ -8898,17 +9021,17 @@
                         <a:buNone/>
                       </a:pPr>
                       <a:r>
-                        <a:rPr lang="en-US" sz="1200" dirty="0">
+                        <a:rPr lang="en-US" sz="1100" dirty="0">
                           <a:solidFill>
                             <a:schemeClr val="tx1"/>
                           </a:solidFill>
                         </a:rPr>
                         <a:t>Plan the migration before end of support forces the timing</a:t>
                       </a:r>
-                      <a:endParaRPr lang="en-US" sz="1200" dirty="0"/>
+                      <a:endParaRPr lang="en-US" sz="1100" dirty="0"/>
                     </a:p>
                   </a:txBody>
-                  <a:tcPr marL="64008" marR="64008" marT="64008" marB="64008" anchor="ctr">
+                  <a:tcPr marL="54864" marR="54864" marT="54864" marB="54864" anchor="ctr">
                     <a:lnL w="6350" cap="flat" cmpd="sng" algn="ctr">
                       <a:solidFill>
                         <a:srgbClr val="D9DEE5"/>
@@ -8959,17 +9082,17 @@
                         <a:buNone/>
                       </a:pPr>
                       <a:r>
-                        <a:rPr lang="en-US" sz="1200" dirty="0">
+                        <a:rPr lang="en-US" sz="1100" dirty="0">
                           <a:solidFill>
                             <a:schemeClr val="tx1"/>
                           </a:solidFill>
                         </a:rPr>
                         <a:t>Propose a migration-path discussion · Offer a site assessment · Offer a lifecycle service review</a:t>
                       </a:r>
-                      <a:endParaRPr lang="en-US" sz="1200" dirty="0"/>
+                      <a:endParaRPr lang="en-US" sz="1100" dirty="0"/>
                     </a:p>
                   </a:txBody>
-                  <a:tcPr marL="64008" marR="64008" marT="64008" marB="64008" anchor="ctr">
+                  <a:tcPr marL="54864" marR="54864" marT="54864" marB="54864" anchor="ctr">
                     <a:lnL w="6350" cap="flat" cmpd="sng" algn="ctr">
                       <a:solidFill>
                         <a:srgbClr val="D9DEE5"/>
@@ -9011,8 +9134,6 @@
                     </a:solidFill>
                   </a:tcPr>
                 </a:tc>
-              </a:tr>
-              <a:tr h="457200">
                 <a:tc>
                   <a:txBody>
                     <a:bodyPr/>
@@ -9022,17 +9143,80 @@
                         <a:buNone/>
                       </a:pPr>
                       <a:r>
-                        <a:rPr lang="en-US" sz="1200" b="1" dirty="0">
+                        <a:rPr lang="en-US" sz="1100" dirty="0">
+                          <a:solidFill>
+                            <a:schemeClr val="tx1"/>
+                          </a:solidFill>
+                        </a:rPr>
+                        <a:t>Their system may be another vendor's: lead with a site assessment and the migration case study, not a lifecycle review.</a:t>
+                      </a:r>
+                      <a:endParaRPr lang="en-US" sz="1100" dirty="0"/>
+                    </a:p>
+                  </a:txBody>
+                  <a:tcPr marL="54864" marR="54864" marT="54864" marB="54864" anchor="ctr">
+                    <a:lnL w="6350" cap="flat" cmpd="sng" algn="ctr">
+                      <a:solidFill>
+                        <a:srgbClr val="D9DEE5"/>
+                      </a:solidFill>
+                      <a:prstDash val="solid"/>
+                      <a:round/>
+                      <a:headEnd type="none" w="med" len="med"/>
+                      <a:tailEnd type="none" w="med" len="med"/>
+                    </a:lnL>
+                    <a:lnR w="6350" cap="flat" cmpd="sng" algn="ctr">
+                      <a:solidFill>
+                        <a:srgbClr val="D9DEE5"/>
+                      </a:solidFill>
+                      <a:prstDash val="solid"/>
+                      <a:round/>
+                      <a:headEnd type="none" w="med" len="med"/>
+                      <a:tailEnd type="none" w="med" len="med"/>
+                    </a:lnR>
+                    <a:lnT w="6350" cap="flat" cmpd="sng" algn="ctr">
+                      <a:solidFill>
+                        <a:srgbClr val="D9DEE5"/>
+                      </a:solidFill>
+                      <a:prstDash val="solid"/>
+                      <a:round/>
+                      <a:headEnd type="none" w="med" len="med"/>
+                      <a:tailEnd type="none" w="med" len="med"/>
+                    </a:lnT>
+                    <a:lnB w="6350" cap="flat" cmpd="sng" algn="ctr">
+                      <a:solidFill>
+                        <a:srgbClr val="D9DEE5"/>
+                      </a:solidFill>
+                      <a:prstDash val="solid"/>
+                      <a:round/>
+                      <a:headEnd type="none" w="med" len="med"/>
+                      <a:tailEnd type="none" w="med" len="med"/>
+                    </a:lnB>
+                    <a:solidFill>
+                      <a:schemeClr val="accent5"/>
+                    </a:solidFill>
+                  </a:tcPr>
+                </a:tc>
+              </a:tr>
+              <a:tr h="566928">
+                <a:tc>
+                  <a:txBody>
+                    <a:bodyPr/>
+                    <a:lstStyle/>
+                    <a:p>
+                      <a:pPr indent="0" marL="0">
+                        <a:buNone/>
+                      </a:pPr>
+                      <a:r>
+                        <a:rPr lang="en-US" sz="1100" b="1" dirty="0">
                           <a:solidFill>
                             <a:schemeClr val="tx1"/>
                           </a:solidFill>
                         </a:rPr>
                         <a:t>Service renewal</a:t>
                       </a:r>
-                      <a:endParaRPr lang="en-US" sz="1200" dirty="0"/>
+                      <a:endParaRPr lang="en-US" sz="1100" dirty="0"/>
                     </a:p>
                   </a:txBody>
-                  <a:tcPr marL="64008" marR="64008" marT="64008" marB="64008" anchor="ctr">
+                  <a:tcPr marL="54864" marR="54864" marT="54864" marB="54864" anchor="ctr">
                     <a:lnL w="6350" cap="flat" cmpd="sng" algn="ctr">
                       <a:solidFill>
                         <a:srgbClr val="D9DEE5"/>
@@ -9083,17 +9267,17 @@
                         <a:buNone/>
                       </a:pPr>
                       <a:r>
-                        <a:rPr lang="en-US" sz="1200" dirty="0">
+                        <a:rPr lang="en-US" sz="1100" dirty="0">
                           <a:solidFill>
                             <a:schemeClr val="tx1"/>
                           </a:solidFill>
                         </a:rPr>
                         <a:t>Service contract renewal</a:t>
                       </a:r>
-                      <a:endParaRPr lang="en-US" sz="1200" dirty="0"/>
+                      <a:endParaRPr lang="en-US" sz="1100" dirty="0"/>
                     </a:p>
                   </a:txBody>
-                  <a:tcPr marL="64008" marR="64008" marT="64008" marB="64008" anchor="ctr">
+                  <a:tcPr marL="54864" marR="54864" marT="54864" marB="54864" anchor="ctr">
                     <a:lnL w="6350" cap="flat" cmpd="sng" algn="ctr">
                       <a:solidFill>
                         <a:srgbClr val="D9DEE5"/>
@@ -9144,17 +9328,17 @@
                         <a:buNone/>
                       </a:pPr>
                       <a:r>
-                        <a:rPr lang="en-US" sz="1200" dirty="0">
+                        <a:rPr lang="en-US" sz="1100" dirty="0">
                           <a:solidFill>
                             <a:schemeClr val="tx1"/>
                           </a:solidFill>
                         </a:rPr>
                         <a:t>Check the cover still fits how the site runs today</a:t>
                       </a:r>
-                      <a:endParaRPr lang="en-US" sz="1200" dirty="0"/>
+                      <a:endParaRPr lang="en-US" sz="1100" dirty="0"/>
                     </a:p>
                   </a:txBody>
-                  <a:tcPr marL="64008" marR="64008" marT="64008" marB="64008" anchor="ctr">
+                  <a:tcPr marL="54864" marR="54864" marT="54864" marB="54864" anchor="ctr">
                     <a:lnL w="6350" cap="flat" cmpd="sng" algn="ctr">
                       <a:solidFill>
                         <a:srgbClr val="D9DEE5"/>
@@ -9205,17 +9389,17 @@
                         <a:buNone/>
                       </a:pPr>
                       <a:r>
-                        <a:rPr lang="en-US" sz="1200" dirty="0">
+                        <a:rPr lang="en-US" sz="1100" dirty="0">
                           <a:solidFill>
                             <a:schemeClr val="tx1"/>
                           </a:solidFill>
                         </a:rPr>
                         <a:t>Offer a renewal review · Route to the service owner</a:t>
                       </a:r>
-                      <a:endParaRPr lang="en-US" sz="1200" dirty="0"/>
+                      <a:endParaRPr lang="en-US" sz="1100" dirty="0"/>
                     </a:p>
                   </a:txBody>
-                  <a:tcPr marL="64008" marR="64008" marT="64008" marB="64008" anchor="ctr">
+                  <a:tcPr marL="54864" marR="54864" marT="54864" marB="54864" anchor="ctr">
                     <a:lnL w="6350" cap="flat" cmpd="sng" algn="ctr">
                       <a:solidFill>
                         <a:srgbClr val="D9DEE5"/>
@@ -9257,8 +9441,6 @@
                     </a:solidFill>
                   </a:tcPr>
                 </a:tc>
-              </a:tr>
-              <a:tr h="457200">
                 <a:tc>
                   <a:txBody>
                     <a:bodyPr/>
@@ -9268,17 +9450,80 @@
                         <a:buNone/>
                       </a:pPr>
                       <a:r>
-                        <a:rPr lang="en-US" sz="1200" b="1" dirty="0">
+                        <a:rPr lang="en-US" sz="1100" dirty="0">
+                          <a:solidFill>
+                            <a:schemeClr val="tx1"/>
+                          </a:solidFill>
+                        </a:rPr>
+                        <a:t>Rarely applies: renewals are with existing customers. A new buyer with a renewal elsewhere is treated as Modernisation.</a:t>
+                      </a:r>
+                      <a:endParaRPr lang="en-US" sz="1100" dirty="0"/>
+                    </a:p>
+                  </a:txBody>
+                  <a:tcPr marL="54864" marR="54864" marT="54864" marB="54864" anchor="ctr">
+                    <a:lnL w="6350" cap="flat" cmpd="sng" algn="ctr">
+                      <a:solidFill>
+                        <a:srgbClr val="D9DEE5"/>
+                      </a:solidFill>
+                      <a:prstDash val="solid"/>
+                      <a:round/>
+                      <a:headEnd type="none" w="med" len="med"/>
+                      <a:tailEnd type="none" w="med" len="med"/>
+                    </a:lnL>
+                    <a:lnR w="6350" cap="flat" cmpd="sng" algn="ctr">
+                      <a:solidFill>
+                        <a:srgbClr val="D9DEE5"/>
+                      </a:solidFill>
+                      <a:prstDash val="solid"/>
+                      <a:round/>
+                      <a:headEnd type="none" w="med" len="med"/>
+                      <a:tailEnd type="none" w="med" len="med"/>
+                    </a:lnR>
+                    <a:lnT w="6350" cap="flat" cmpd="sng" algn="ctr">
+                      <a:solidFill>
+                        <a:srgbClr val="D9DEE5"/>
+                      </a:solidFill>
+                      <a:prstDash val="solid"/>
+                      <a:round/>
+                      <a:headEnd type="none" w="med" len="med"/>
+                      <a:tailEnd type="none" w="med" len="med"/>
+                    </a:lnT>
+                    <a:lnB w="6350" cap="flat" cmpd="sng" algn="ctr">
+                      <a:solidFill>
+                        <a:srgbClr val="D9DEE5"/>
+                      </a:solidFill>
+                      <a:prstDash val="solid"/>
+                      <a:round/>
+                      <a:headEnd type="none" w="med" len="med"/>
+                      <a:tailEnd type="none" w="med" len="med"/>
+                    </a:lnB>
+                    <a:solidFill>
+                      <a:schemeClr val="accent5"/>
+                    </a:solidFill>
+                  </a:tcPr>
+                </a:tc>
+              </a:tr>
+              <a:tr h="566928">
+                <a:tc>
+                  <a:txBody>
+                    <a:bodyPr/>
+                    <a:lstStyle/>
+                    <a:p>
+                      <a:pPr indent="0" marL="0">
+                        <a:buNone/>
+                      </a:pPr>
+                      <a:r>
+                        <a:rPr lang="en-US" sz="1100" b="1" dirty="0">
                           <a:solidFill>
                             <a:schemeClr val="tx1"/>
                           </a:solidFill>
                         </a:rPr>
                         <a:t>Project</a:t>
                       </a:r>
-                      <a:endParaRPr lang="en-US" sz="1200" dirty="0"/>
+                      <a:endParaRPr lang="en-US" sz="1100" dirty="0"/>
                     </a:p>
                   </a:txBody>
-                  <a:tcPr marL="64008" marR="64008" marT="64008" marB="64008" anchor="ctr">
+                  <a:tcPr marL="54864" marR="54864" marT="54864" marB="54864" anchor="ctr">
                     <a:lnL w="6350" cap="flat" cmpd="sng" algn="ctr">
                       <a:solidFill>
                         <a:srgbClr val="D9DEE5"/>
@@ -9329,17 +9574,17 @@
                         <a:buNone/>
                       </a:pPr>
                       <a:r>
-                        <a:rPr lang="en-US" sz="1200" dirty="0">
+                        <a:rPr lang="en-US" sz="1100" dirty="0">
                           <a:solidFill>
                             <a:schemeClr val="tx1"/>
                           </a:solidFill>
                         </a:rPr>
                         <a:t>Capital project</a:t>
                       </a:r>
-                      <a:endParaRPr lang="en-US" sz="1200" dirty="0"/>
+                      <a:endParaRPr lang="en-US" sz="1100" dirty="0"/>
                     </a:p>
                   </a:txBody>
-                  <a:tcPr marL="64008" marR="64008" marT="64008" marB="64008" anchor="ctr">
+                  <a:tcPr marL="54864" marR="54864" marT="54864" marB="54864" anchor="ctr">
                     <a:lnL w="6350" cap="flat" cmpd="sng" algn="ctr">
                       <a:solidFill>
                         <a:srgbClr val="D9DEE5"/>
@@ -9390,17 +9635,17 @@
                         <a:buNone/>
                       </a:pPr>
                       <a:r>
-                        <a:rPr lang="en-US" sz="1200" dirty="0">
+                        <a:rPr lang="en-US" sz="1100" dirty="0">
                           <a:solidFill>
                             <a:schemeClr val="tx1"/>
                           </a:solidFill>
                         </a:rPr>
                         <a:t>Settle the control scope while the design is still open</a:t>
                       </a:r>
-                      <a:endParaRPr lang="en-US" sz="1200" dirty="0"/>
+                      <a:endParaRPr lang="en-US" sz="1100" dirty="0"/>
                     </a:p>
                   </a:txBody>
-                  <a:tcPr marL="64008" marR="64008" marT="64008" marB="64008" anchor="ctr">
+                  <a:tcPr marL="54864" marR="54864" marT="54864" marB="54864" anchor="ctr">
                     <a:lnL w="6350" cap="flat" cmpd="sng" algn="ctr">
                       <a:solidFill>
                         <a:srgbClr val="D9DEE5"/>
@@ -9451,17 +9696,17 @@
                         <a:buNone/>
                       </a:pPr>
                       <a:r>
-                        <a:rPr lang="en-US" sz="1200" dirty="0">
+                        <a:rPr lang="en-US" sz="1100" dirty="0">
                           <a:solidFill>
                             <a:schemeClr val="tx1"/>
                           </a:solidFill>
                         </a:rPr>
                         <a:t>Share a case study and offer a technical session · Offer a reference-site visit · Offer an early design workshop</a:t>
                       </a:r>
-                      <a:endParaRPr lang="en-US" sz="1200" dirty="0"/>
+                      <a:endParaRPr lang="en-US" sz="1100" dirty="0"/>
                     </a:p>
                   </a:txBody>
-                  <a:tcPr marL="64008" marR="64008" marT="64008" marB="64008" anchor="ctr">
+                  <a:tcPr marL="54864" marR="54864" marT="54864" marB="54864" anchor="ctr">
                     <a:lnL w="6350" cap="flat" cmpd="sng" algn="ctr">
                       <a:solidFill>
                         <a:srgbClr val="D9DEE5"/>
@@ -9503,8 +9748,6 @@
                     </a:solidFill>
                   </a:tcPr>
                 </a:tc>
-              </a:tr>
-              <a:tr h="457200">
                 <a:tc>
                   <a:txBody>
                     <a:bodyPr/>
@@ -9514,17 +9757,80 @@
                         <a:buNone/>
                       </a:pPr>
                       <a:r>
-                        <a:rPr lang="en-US" sz="1200" b="1" dirty="0">
+                        <a:rPr lang="en-US" sz="1100" dirty="0">
+                          <a:solidFill>
+                            <a:schemeClr val="tx1"/>
+                          </a:solidFill>
+                        </a:rPr>
+                        <a:t>The best way in: the plant-expansion case study, then a reference-site visit so they see a similar site running.</a:t>
+                      </a:r>
+                      <a:endParaRPr lang="en-US" sz="1100" dirty="0"/>
+                    </a:p>
+                  </a:txBody>
+                  <a:tcPr marL="54864" marR="54864" marT="54864" marB="54864" anchor="ctr">
+                    <a:lnL w="6350" cap="flat" cmpd="sng" algn="ctr">
+                      <a:solidFill>
+                        <a:srgbClr val="D9DEE5"/>
+                      </a:solidFill>
+                      <a:prstDash val="solid"/>
+                      <a:round/>
+                      <a:headEnd type="none" w="med" len="med"/>
+                      <a:tailEnd type="none" w="med" len="med"/>
+                    </a:lnL>
+                    <a:lnR w="6350" cap="flat" cmpd="sng" algn="ctr">
+                      <a:solidFill>
+                        <a:srgbClr val="D9DEE5"/>
+                      </a:solidFill>
+                      <a:prstDash val="solid"/>
+                      <a:round/>
+                      <a:headEnd type="none" w="med" len="med"/>
+                      <a:tailEnd type="none" w="med" len="med"/>
+                    </a:lnR>
+                    <a:lnT w="6350" cap="flat" cmpd="sng" algn="ctr">
+                      <a:solidFill>
+                        <a:srgbClr val="D9DEE5"/>
+                      </a:solidFill>
+                      <a:prstDash val="solid"/>
+                      <a:round/>
+                      <a:headEnd type="none" w="med" len="med"/>
+                      <a:tailEnd type="none" w="med" len="med"/>
+                    </a:lnT>
+                    <a:lnB w="6350" cap="flat" cmpd="sng" algn="ctr">
+                      <a:solidFill>
+                        <a:srgbClr val="D9DEE5"/>
+                      </a:solidFill>
+                      <a:prstDash val="solid"/>
+                      <a:round/>
+                      <a:headEnd type="none" w="med" len="med"/>
+                      <a:tailEnd type="none" w="med" len="med"/>
+                    </a:lnB>
+                    <a:solidFill>
+                      <a:schemeClr val="accent5"/>
+                    </a:solidFill>
+                  </a:tcPr>
+                </a:tc>
+              </a:tr>
+              <a:tr h="566928">
+                <a:tc>
+                  <a:txBody>
+                    <a:bodyPr/>
+                    <a:lstStyle/>
+                    <a:p>
+                      <a:pPr indent="0" marL="0">
+                        <a:buNone/>
+                      </a:pPr>
+                      <a:r>
+                        <a:rPr lang="en-US" sz="1100" b="1" dirty="0">
                           <a:solidFill>
                             <a:schemeClr val="tx1"/>
                           </a:solidFill>
                         </a:rPr>
                         <a:t>Leadership</a:t>
                       </a:r>
-                      <a:endParaRPr lang="en-US" sz="1200" dirty="0"/>
+                      <a:endParaRPr lang="en-US" sz="1100" dirty="0"/>
                     </a:p>
                   </a:txBody>
-                  <a:tcPr marL="64008" marR="64008" marT="64008" marB="64008" anchor="ctr">
+                  <a:tcPr marL="54864" marR="54864" marT="54864" marB="54864" anchor="ctr">
                     <a:lnL w="6350" cap="flat" cmpd="sng" algn="ctr">
                       <a:solidFill>
                         <a:srgbClr val="D9DEE5"/>
@@ -9575,17 +9881,17 @@
                         <a:buNone/>
                       </a:pPr>
                       <a:r>
-                        <a:rPr lang="en-US" sz="1200" dirty="0">
+                        <a:rPr lang="en-US" sz="1100" dirty="0">
                           <a:solidFill>
                             <a:schemeClr val="tx1"/>
                           </a:solidFill>
                         </a:rPr>
                         <a:t>Leadership change</a:t>
                       </a:r>
-                      <a:endParaRPr lang="en-US" sz="1200" dirty="0"/>
+                      <a:endParaRPr lang="en-US" sz="1100" dirty="0"/>
                     </a:p>
                   </a:txBody>
-                  <a:tcPr marL="64008" marR="64008" marT="64008" marB="64008" anchor="ctr">
+                  <a:tcPr marL="54864" marR="54864" marT="54864" marB="54864" anchor="ctr">
                     <a:lnL w="6350" cap="flat" cmpd="sng" algn="ctr">
                       <a:solidFill>
                         <a:srgbClr val="D9DEE5"/>
@@ -9636,17 +9942,17 @@
                         <a:buNone/>
                       </a:pPr>
                       <a:r>
-                        <a:rPr lang="en-US" sz="1200" dirty="0">
+                        <a:rPr lang="en-US" sz="1100" dirty="0">
                           <a:solidFill>
                             <a:schemeClr val="tx1"/>
                           </a:solidFill>
                         </a:rPr>
                         <a:t>Be useful to a new leader setting priorities</a:t>
                       </a:r>
-                      <a:endParaRPr lang="en-US" sz="1200" dirty="0"/>
+                      <a:endParaRPr lang="en-US" sz="1100" dirty="0"/>
                     </a:p>
                   </a:txBody>
-                  <a:tcPr marL="64008" marR="64008" marT="64008" marB="64008" anchor="ctr">
+                  <a:tcPr marL="54864" marR="54864" marT="54864" marB="54864" anchor="ctr">
                     <a:lnL w="6350" cap="flat" cmpd="sng" algn="ctr">
                       <a:solidFill>
                         <a:srgbClr val="D9DEE5"/>
@@ -9697,17 +10003,17 @@
                         <a:buNone/>
                       </a:pPr>
                       <a:r>
-                        <a:rPr lang="en-US" sz="1200" dirty="0">
+                        <a:rPr lang="en-US" sz="1100" dirty="0">
                           <a:solidFill>
                             <a:schemeClr val="tx1"/>
                           </a:solidFill>
                         </a:rPr>
                         <a:t>Introduce Client to the new leader · Share a peer case study · Invite to a short briefing</a:t>
                       </a:r>
-                      <a:endParaRPr lang="en-US" sz="1200" dirty="0"/>
+                      <a:endParaRPr lang="en-US" sz="1100" dirty="0"/>
                     </a:p>
                   </a:txBody>
-                  <a:tcPr marL="64008" marR="64008" marT="64008" marB="64008" anchor="ctr">
+                  <a:tcPr marL="54864" marR="54864" marT="54864" marB="54864" anchor="ctr">
                     <a:lnL w="6350" cap="flat" cmpd="sng" algn="ctr">
                       <a:solidFill>
                         <a:srgbClr val="D9DEE5"/>
@@ -9749,8 +10055,6 @@
                     </a:solidFill>
                   </a:tcPr>
                 </a:tc>
-              </a:tr>
-              <a:tr h="457200">
                 <a:tc>
                   <a:txBody>
                     <a:bodyPr/>
@@ -9760,17 +10064,80 @@
                         <a:buNone/>
                       </a:pPr>
                       <a:r>
-                        <a:rPr lang="en-US" sz="1200" b="1" dirty="0">
+                        <a:rPr lang="en-US" sz="1100" dirty="0">
+                          <a:solidFill>
+                            <a:schemeClr val="tx1"/>
+                          </a:solidFill>
+                        </a:rPr>
+                        <a:t>Introduce Client and what comparable sites run; share the peer story on first-100-day priorities.</a:t>
+                      </a:r>
+                      <a:endParaRPr lang="en-US" sz="1100" dirty="0"/>
+                    </a:p>
+                  </a:txBody>
+                  <a:tcPr marL="54864" marR="54864" marT="54864" marB="54864" anchor="ctr">
+                    <a:lnL w="6350" cap="flat" cmpd="sng" algn="ctr">
+                      <a:solidFill>
+                        <a:srgbClr val="D9DEE5"/>
+                      </a:solidFill>
+                      <a:prstDash val="solid"/>
+                      <a:round/>
+                      <a:headEnd type="none" w="med" len="med"/>
+                      <a:tailEnd type="none" w="med" len="med"/>
+                    </a:lnL>
+                    <a:lnR w="6350" cap="flat" cmpd="sng" algn="ctr">
+                      <a:solidFill>
+                        <a:srgbClr val="D9DEE5"/>
+                      </a:solidFill>
+                      <a:prstDash val="solid"/>
+                      <a:round/>
+                      <a:headEnd type="none" w="med" len="med"/>
+                      <a:tailEnd type="none" w="med" len="med"/>
+                    </a:lnR>
+                    <a:lnT w="6350" cap="flat" cmpd="sng" algn="ctr">
+                      <a:solidFill>
+                        <a:srgbClr val="D9DEE5"/>
+                      </a:solidFill>
+                      <a:prstDash val="solid"/>
+                      <a:round/>
+                      <a:headEnd type="none" w="med" len="med"/>
+                      <a:tailEnd type="none" w="med" len="med"/>
+                    </a:lnT>
+                    <a:lnB w="6350" cap="flat" cmpd="sng" algn="ctr">
+                      <a:solidFill>
+                        <a:srgbClr val="D9DEE5"/>
+                      </a:solidFill>
+                      <a:prstDash val="solid"/>
+                      <a:round/>
+                      <a:headEnd type="none" w="med" len="med"/>
+                      <a:tailEnd type="none" w="med" len="med"/>
+                    </a:lnB>
+                    <a:solidFill>
+                      <a:schemeClr val="accent5"/>
+                    </a:solidFill>
+                  </a:tcPr>
+                </a:tc>
+              </a:tr>
+              <a:tr h="566928">
+                <a:tc>
+                  <a:txBody>
+                    <a:bodyPr/>
+                    <a:lstStyle/>
+                    <a:p>
+                      <a:pPr indent="0" marL="0">
+                        <a:buNone/>
+                      </a:pPr>
+                      <a:r>
+                        <a:rPr lang="en-US" sz="1100" b="1" dirty="0">
                           <a:solidFill>
                             <a:schemeClr val="tx1"/>
                           </a:solidFill>
                         </a:rPr>
                         <a:t>Engagement</a:t>
                       </a:r>
-                      <a:endParaRPr lang="en-US" sz="1200" dirty="0"/>
+                      <a:endParaRPr lang="en-US" sz="1100" dirty="0"/>
                     </a:p>
                   </a:txBody>
-                  <a:tcPr marL="64008" marR="64008" marT="64008" marB="64008" anchor="ctr">
+                  <a:tcPr marL="54864" marR="54864" marT="54864" marB="54864" anchor="ctr">
                     <a:lnL w="6350" cap="flat" cmpd="sng" algn="ctr">
                       <a:solidFill>
                         <a:srgbClr val="D9DEE5"/>
@@ -9821,17 +10188,17 @@
                         <a:buNone/>
                       </a:pPr>
                       <a:r>
-                        <a:rPr lang="en-US" sz="1200" dirty="0">
+                        <a:rPr lang="en-US" sz="1100" dirty="0">
                           <a:solidFill>
                             <a:schemeClr val="tx1"/>
                           </a:solidFill>
                         </a:rPr>
                         <a:t>Webinar, download or email click</a:t>
                       </a:r>
-                      <a:endParaRPr lang="en-US" sz="1200" dirty="0"/>
+                      <a:endParaRPr lang="en-US" sz="1100" dirty="0"/>
                     </a:p>
                   </a:txBody>
-                  <a:tcPr marL="64008" marR="64008" marT="64008" marB="64008" anchor="ctr">
+                  <a:tcPr marL="54864" marR="54864" marT="54864" marB="54864" anchor="ctr">
                     <a:lnL w="6350" cap="flat" cmpd="sng" algn="ctr">
                       <a:solidFill>
                         <a:srgbClr val="D9DEE5"/>
@@ -9882,17 +10249,17 @@
                         <a:buNone/>
                       </a:pPr>
                       <a:r>
-                        <a:rPr lang="en-US" sz="1200" dirty="0">
+                        <a:rPr lang="en-US" sz="1100" dirty="0">
                           <a:solidFill>
                             <a:schemeClr val="tx1"/>
                           </a:solidFill>
                         </a:rPr>
                         <a:t>Follow up on the topic they chose to engage with</a:t>
                       </a:r>
-                      <a:endParaRPr lang="en-US" sz="1200" dirty="0"/>
+                      <a:endParaRPr lang="en-US" sz="1100" dirty="0"/>
                     </a:p>
                   </a:txBody>
-                  <a:tcPr marL="64008" marR="64008" marT="64008" marB="64008" anchor="ctr">
+                  <a:tcPr marL="54864" marR="54864" marT="54864" marB="54864" anchor="ctr">
                     <a:lnL w="6350" cap="flat" cmpd="sng" algn="ctr">
                       <a:solidFill>
                         <a:srgbClr val="D9DEE5"/>
@@ -9943,17 +10310,17 @@
                         <a:buNone/>
                       </a:pPr>
                       <a:r>
-                        <a:rPr lang="en-US" sz="1200" dirty="0">
+                        <a:rPr lang="en-US" sz="1100" dirty="0">
                           <a:solidFill>
                             <a:schemeClr val="tx1"/>
                           </a:solidFill>
                         </a:rPr>
                         <a:t>Follow up on the topic they engaged with · Invite to a related session</a:t>
                       </a:r>
-                      <a:endParaRPr lang="en-US" sz="1200" dirty="0"/>
+                      <a:endParaRPr lang="en-US" sz="1100" dirty="0"/>
                     </a:p>
                   </a:txBody>
-                  <a:tcPr marL="64008" marR="64008" marT="64008" marB="64008" anchor="ctr">
+                  <a:tcPr marL="54864" marR="54864" marT="54864" marB="54864" anchor="ctr">
                     <a:lnL w="6350" cap="flat" cmpd="sng" algn="ctr">
                       <a:solidFill>
                         <a:srgbClr val="D9DEE5"/>
@@ -9992,6 +10359,67 @@
                     </a:lnB>
                     <a:solidFill>
                       <a:schemeClr val="bg1"/>
+                    </a:solidFill>
+                  </a:tcPr>
+                </a:tc>
+                <a:tc>
+                  <a:txBody>
+                    <a:bodyPr/>
+                    <a:lstStyle/>
+                    <a:p>
+                      <a:pPr indent="0" marL="0">
+                        <a:buNone/>
+                      </a:pPr>
+                      <a:r>
+                        <a:rPr lang="en-US" sz="1100" dirty="0">
+                          <a:solidFill>
+                            <a:schemeClr val="tx1"/>
+                          </a:solidFill>
+                        </a:rPr>
+                        <a:t>Send the session recording and invite them to a related session; no sales ask yet.</a:t>
+                      </a:r>
+                      <a:endParaRPr lang="en-US" sz="1100" dirty="0"/>
+                    </a:p>
+                  </a:txBody>
+                  <a:tcPr marL="54864" marR="54864" marT="54864" marB="54864" anchor="ctr">
+                    <a:lnL w="6350" cap="flat" cmpd="sng" algn="ctr">
+                      <a:solidFill>
+                        <a:srgbClr val="D9DEE5"/>
+                      </a:solidFill>
+                      <a:prstDash val="solid"/>
+                      <a:round/>
+                      <a:headEnd type="none" w="med" len="med"/>
+                      <a:tailEnd type="none" w="med" len="med"/>
+                    </a:lnL>
+                    <a:lnR w="6350" cap="flat" cmpd="sng" algn="ctr">
+                      <a:solidFill>
+                        <a:srgbClr val="D9DEE5"/>
+                      </a:solidFill>
+                      <a:prstDash val="solid"/>
+                      <a:round/>
+                      <a:headEnd type="none" w="med" len="med"/>
+                      <a:tailEnd type="none" w="med" len="med"/>
+                    </a:lnR>
+                    <a:lnT w="6350" cap="flat" cmpd="sng" algn="ctr">
+                      <a:solidFill>
+                        <a:srgbClr val="D9DEE5"/>
+                      </a:solidFill>
+                      <a:prstDash val="solid"/>
+                      <a:round/>
+                      <a:headEnd type="none" w="med" len="med"/>
+                      <a:tailEnd type="none" w="med" len="med"/>
+                    </a:lnT>
+                    <a:lnB w="6350" cap="flat" cmpd="sng" algn="ctr">
+                      <a:solidFill>
+                        <a:srgbClr val="D9DEE5"/>
+                      </a:solidFill>
+                      <a:prstDash val="solid"/>
+                      <a:round/>
+                      <a:headEnd type="none" w="med" len="med"/>
+                      <a:tailEnd type="none" w="med" len="med"/>
+                    </a:lnB>
+                    <a:solidFill>
+                      <a:schemeClr val="accent5"/>
                     </a:solidFill>
                   </a:tcPr>
                 </a:tc>
@@ -10008,8 +10436,8 @@
         </p:nvSpPr>
         <p:spPr>
           <a:xfrm>
-            <a:off x="548640" y="4956048"/>
-            <a:ext cx="5486400" cy="274320"/>
+            <a:off x="548640" y="5852160"/>
+            <a:ext cx="11094415" cy="411480"/>
           </a:xfrm>
           <a:prstGeom prst="rect">
             <a:avLst/>
@@ -10018,435 +10446,32 @@
           <a:ln/>
         </p:spPr>
         <p:txBody>
-          <a:bodyPr wrap="square" lIns="0" tIns="0" rIns="0" bIns="0" rtlCol="0" anchor="t"/>
+          <a:bodyPr wrap="square" lIns="0" tIns="0" rIns="0" bIns="0" rtlCol="0" anchor="ctr"/>
           <a:lstStyle/>
           <a:p>
             <a:pPr indent="0" marL="0">
               <a:buNone/>
             </a:pPr>
             <a:r>
-              <a:rPr lang="en-US" sz="1200" b="1" spc="150" kern="0" dirty="0">
-                <a:solidFill>
-                  <a:schemeClr val="accent3"/>
-                </a:solidFill>
-              </a:rPr>
-              <a:t>HOW THE NEXT BEST ACTION IS CHOSEN</a:t>
-            </a:r>
-            <a:endParaRPr lang="en-US" sz="1200" dirty="0"/>
-          </a:p>
-        </p:txBody>
-      </p:sp>
-      <p:sp>
-        <p:nvSpPr>
-          <p:cNvPr id="6" name="Shape 3"/>
-          <p:cNvSpPr/>
-          <p:nvPr/>
-        </p:nvSpPr>
-        <p:spPr>
-          <a:xfrm>
-            <a:off x="548640" y="5285232"/>
-            <a:ext cx="3566160" cy="914400"/>
-          </a:xfrm>
-          <a:prstGeom prst="roundRect">
-            <a:avLst>
-              <a:gd name="adj" fmla="val 8000"/>
-            </a:avLst>
-          </a:prstGeom>
-          <a:solidFill>
-            <a:schemeClr val="accent5"/>
-          </a:solidFill>
-          <a:ln w="12700">
-            <a:solidFill>
-              <a:schemeClr val="accent5"/>
-            </a:solidFill>
-            <a:prstDash val="solid"/>
-          </a:ln>
-        </p:spPr>
-      </p:sp>
-      <p:sp>
-        <p:nvSpPr>
-          <p:cNvPr id="7" name="Shape 4"/>
-          <p:cNvSpPr/>
-          <p:nvPr/>
-        </p:nvSpPr>
-        <p:spPr>
-          <a:xfrm>
-            <a:off x="731520" y="5532120"/>
-            <a:ext cx="411480" cy="411480"/>
-          </a:xfrm>
-          <a:prstGeom prst="ellipse">
-            <a:avLst/>
-          </a:prstGeom>
-          <a:solidFill>
-            <a:schemeClr val="accent1"/>
-          </a:solidFill>
-          <a:ln w="12700">
-            <a:solidFill>
-              <a:schemeClr val="accent1"/>
-            </a:solidFill>
-            <a:prstDash val="solid"/>
-          </a:ln>
-        </p:spPr>
-      </p:sp>
-      <p:sp>
-        <p:nvSpPr>
-          <p:cNvPr id="8" name="Text 5"/>
-          <p:cNvSpPr txBox="1"/>
-          <p:nvPr/>
-        </p:nvSpPr>
-        <p:spPr>
-          <a:xfrm>
-            <a:off x="731520" y="5532120"/>
-            <a:ext cx="411480" cy="411480"/>
-          </a:xfrm>
-          <a:prstGeom prst="rect">
-            <a:avLst/>
-          </a:prstGeom>
-          <a:noFill/>
-          <a:ln/>
-        </p:spPr>
-        <p:txBody>
-          <a:bodyPr wrap="square" lIns="0" tIns="0" rIns="0" bIns="0" rtlCol="0" anchor="ctr"/>
-          <a:lstStyle/>
-          <a:p>
-            <a:pPr algn="ctr" indent="0" marL="0">
-              <a:buNone/>
-            </a:pPr>
-            <a:r>
-              <a:rPr lang="en-US" sz="1300" b="1" dirty="0">
-                <a:solidFill>
-                  <a:schemeClr val="tx1"/>
-                </a:solidFill>
-              </a:rPr>
-              <a:t>1</a:t>
-            </a:r>
-            <a:endParaRPr lang="en-US" sz="1300" dirty="0"/>
-          </a:p>
-        </p:txBody>
-      </p:sp>
-      <p:sp>
-        <p:nvSpPr>
-          <p:cNvPr id="9" name="Text 6"/>
-          <p:cNvSpPr txBox="1"/>
-          <p:nvPr/>
-        </p:nvSpPr>
-        <p:spPr>
-          <a:xfrm>
-            <a:off x="1280160" y="5285232"/>
-            <a:ext cx="2697480" cy="914400"/>
-          </a:xfrm>
-          <a:prstGeom prst="rect">
-            <a:avLst/>
-          </a:prstGeom>
-          <a:noFill/>
-          <a:ln/>
-        </p:spPr>
-        <p:txBody>
-          <a:bodyPr wrap="square" lIns="0" tIns="0" rIns="0" bIns="0" rtlCol="0" anchor="ctr"/>
-          <a:lstStyle/>
-          <a:p>
+              <a:rPr lang="en-US" sz="1250" b="1" dirty="0">
+                <a:solidFill>
+                  <a:schemeClr val="tx2"/>
+                </a:solidFill>
+              </a:rPr>
+              <a:t>How the action is chosen: </a:t>
+            </a:r>
             <a:pPr indent="0" marL="0">
               <a:buNone/>
             </a:pPr>
             <a:r>
-              <a:rPr lang="en-US" sz="1450" b="1" dirty="0">
-                <a:solidFill>
-                  <a:schemeClr val="tx1"/>
-                </a:solidFill>
-              </a:rPr>
-              <a:t>Your inputs</a:t>
-            </a:r>
-            <a:endParaRPr lang="en-US" sz="1400" dirty="0"/>
-          </a:p>
-          <a:p>
-            <a:pPr indent="0" marL="0">
-              <a:buNone/>
-            </a:pPr>
-            <a:r>
-              <a:rPr lang="en-US" sz="1200" dirty="0">
-                <a:solidFill>
-                  <a:schemeClr val="tx1"/>
-                </a:solidFill>
-              </a:rPr>
-              <a:t>Your team sets the segments and actions in Setup; they guide the AI.</a:t>
-            </a:r>
-            <a:endParaRPr lang="en-US" sz="1400" dirty="0"/>
-          </a:p>
-        </p:txBody>
-      </p:sp>
-      <p:sp>
-        <p:nvSpPr>
-          <p:cNvPr id="10" name="Shape 7"/>
-          <p:cNvSpPr/>
-          <p:nvPr/>
-        </p:nvSpPr>
-        <p:spPr>
-          <a:xfrm>
-            <a:off x="4279392" y="5285232"/>
-            <a:ext cx="3566160" cy="914400"/>
-          </a:xfrm>
-          <a:prstGeom prst="roundRect">
-            <a:avLst>
-              <a:gd name="adj" fmla="val 8000"/>
-            </a:avLst>
-          </a:prstGeom>
-          <a:solidFill>
-            <a:schemeClr val="tx1"/>
-          </a:solidFill>
-          <a:ln w="12700">
-            <a:solidFill>
-              <a:schemeClr val="tx1"/>
-            </a:solidFill>
-            <a:prstDash val="solid"/>
-          </a:ln>
-        </p:spPr>
-      </p:sp>
-      <p:sp>
-        <p:nvSpPr>
-          <p:cNvPr id="11" name="Shape 8"/>
-          <p:cNvSpPr/>
-          <p:nvPr/>
-        </p:nvSpPr>
-        <p:spPr>
-          <a:xfrm>
-            <a:off x="4462272" y="5532120"/>
-            <a:ext cx="411480" cy="411480"/>
-          </a:xfrm>
-          <a:prstGeom prst="ellipse">
-            <a:avLst/>
-          </a:prstGeom>
-          <a:solidFill>
-            <a:schemeClr val="accent1"/>
-          </a:solidFill>
-          <a:ln w="12700">
-            <a:solidFill>
-              <a:schemeClr val="accent1"/>
-            </a:solidFill>
-            <a:prstDash val="solid"/>
-          </a:ln>
-        </p:spPr>
-      </p:sp>
-      <p:sp>
-        <p:nvSpPr>
-          <p:cNvPr id="12" name="Text 9"/>
-          <p:cNvSpPr txBox="1"/>
-          <p:nvPr/>
-        </p:nvSpPr>
-        <p:spPr>
-          <a:xfrm>
-            <a:off x="4462272" y="5532120"/>
-            <a:ext cx="411480" cy="411480"/>
-          </a:xfrm>
-          <a:prstGeom prst="rect">
-            <a:avLst/>
-          </a:prstGeom>
-          <a:noFill/>
-          <a:ln/>
-        </p:spPr>
-        <p:txBody>
-          <a:bodyPr wrap="square" lIns="0" tIns="0" rIns="0" bIns="0" rtlCol="0" anchor="ctr"/>
-          <a:lstStyle/>
-          <a:p>
-            <a:pPr algn="ctr" indent="0" marL="0">
-              <a:buNone/>
-            </a:pPr>
-            <a:r>
-              <a:rPr lang="en-US" sz="1300" b="1" dirty="0">
-                <a:solidFill>
-                  <a:schemeClr val="tx1"/>
-                </a:solidFill>
-              </a:rPr>
-              <a:t>2</a:t>
-            </a:r>
-            <a:endParaRPr lang="en-US" sz="1300" dirty="0"/>
-          </a:p>
-        </p:txBody>
-      </p:sp>
-      <p:sp>
-        <p:nvSpPr>
-          <p:cNvPr id="13" name="Text 10"/>
-          <p:cNvSpPr txBox="1"/>
-          <p:nvPr/>
-        </p:nvSpPr>
-        <p:spPr>
-          <a:xfrm>
-            <a:off x="5010912" y="5285232"/>
-            <a:ext cx="2697480" cy="914400"/>
-          </a:xfrm>
-          <a:prstGeom prst="rect">
-            <a:avLst/>
-          </a:prstGeom>
-          <a:noFill/>
-          <a:ln/>
-        </p:spPr>
-        <p:txBody>
-          <a:bodyPr wrap="square" lIns="0" tIns="0" rIns="0" bIns="0" rtlCol="0" anchor="ctr"/>
-          <a:lstStyle/>
-          <a:p>
-            <a:pPr indent="0" marL="0">
-              <a:buNone/>
-            </a:pPr>
-            <a:r>
-              <a:rPr lang="en-US" sz="1450" b="1" dirty="0">
-                <a:solidFill>
-                  <a:schemeClr val="bg1"/>
-                </a:solidFill>
-              </a:rPr>
-              <a:t>AI decides</a:t>
-            </a:r>
-            <a:endParaRPr lang="en-US" sz="1400" dirty="0"/>
-          </a:p>
-          <a:p>
-            <a:pPr indent="0" marL="0">
-              <a:buNone/>
-            </a:pPr>
-            <a:r>
-              <a:rPr lang="en-US" sz="1200" dirty="0">
-                <a:solidFill>
-                  <a:schemeClr val="bg1"/>
-                </a:solidFill>
-              </a:rPr>
-              <a:t>The AI picks the action that fits the signal, the person and the account.</a:t>
-            </a:r>
-            <a:endParaRPr lang="en-US" sz="1400" dirty="0"/>
-          </a:p>
-        </p:txBody>
-      </p:sp>
-      <p:sp>
-        <p:nvSpPr>
-          <p:cNvPr id="14" name="Shape 11"/>
-          <p:cNvSpPr/>
-          <p:nvPr/>
-        </p:nvSpPr>
-        <p:spPr>
-          <a:xfrm>
-            <a:off x="8010144" y="5285232"/>
-            <a:ext cx="3566160" cy="914400"/>
-          </a:xfrm>
-          <a:prstGeom prst="roundRect">
-            <a:avLst>
-              <a:gd name="adj" fmla="val 8000"/>
-            </a:avLst>
-          </a:prstGeom>
-          <a:solidFill>
-            <a:schemeClr val="accent5"/>
-          </a:solidFill>
-          <a:ln w="12700">
-            <a:solidFill>
-              <a:schemeClr val="accent5"/>
-            </a:solidFill>
-            <a:prstDash val="solid"/>
-          </a:ln>
-        </p:spPr>
-      </p:sp>
-      <p:sp>
-        <p:nvSpPr>
-          <p:cNvPr id="15" name="Shape 12"/>
-          <p:cNvSpPr/>
-          <p:nvPr/>
-        </p:nvSpPr>
-        <p:spPr>
-          <a:xfrm>
-            <a:off x="8193024" y="5532120"/>
-            <a:ext cx="411480" cy="411480"/>
-          </a:xfrm>
-          <a:prstGeom prst="ellipse">
-            <a:avLst/>
-          </a:prstGeom>
-          <a:solidFill>
-            <a:schemeClr val="accent1"/>
-          </a:solidFill>
-          <a:ln w="12700">
-            <a:solidFill>
-              <a:schemeClr val="accent1"/>
-            </a:solidFill>
-            <a:prstDash val="solid"/>
-          </a:ln>
-        </p:spPr>
-      </p:sp>
-      <p:sp>
-        <p:nvSpPr>
-          <p:cNvPr id="16" name="Text 13"/>
-          <p:cNvSpPr txBox="1"/>
-          <p:nvPr/>
-        </p:nvSpPr>
-        <p:spPr>
-          <a:xfrm>
-            <a:off x="8193024" y="5532120"/>
-            <a:ext cx="411480" cy="411480"/>
-          </a:xfrm>
-          <a:prstGeom prst="rect">
-            <a:avLst/>
-          </a:prstGeom>
-          <a:noFill/>
-          <a:ln/>
-        </p:spPr>
-        <p:txBody>
-          <a:bodyPr wrap="square" lIns="0" tIns="0" rIns="0" bIns="0" rtlCol="0" anchor="ctr"/>
-          <a:lstStyle/>
-          <a:p>
-            <a:pPr algn="ctr" indent="0" marL="0">
-              <a:buNone/>
-            </a:pPr>
-            <a:r>
-              <a:rPr lang="en-US" sz="1300" b="1" dirty="0">
-                <a:solidFill>
-                  <a:schemeClr val="tx1"/>
-                </a:solidFill>
-              </a:rPr>
-              <a:t>3</a:t>
-            </a:r>
-            <a:endParaRPr lang="en-US" sz="1300" dirty="0"/>
-          </a:p>
-        </p:txBody>
-      </p:sp>
-      <p:sp>
-        <p:nvSpPr>
-          <p:cNvPr id="17" name="Text 14"/>
-          <p:cNvSpPr txBox="1"/>
-          <p:nvPr/>
-        </p:nvSpPr>
-        <p:spPr>
-          <a:xfrm>
-            <a:off x="8741664" y="5285232"/>
-            <a:ext cx="2697480" cy="914400"/>
-          </a:xfrm>
-          <a:prstGeom prst="rect">
-            <a:avLst/>
-          </a:prstGeom>
-          <a:noFill/>
-          <a:ln/>
-        </p:spPr>
-        <p:txBody>
-          <a:bodyPr wrap="square" lIns="0" tIns="0" rIns="0" bIns="0" rtlCol="0" anchor="ctr"/>
-          <a:lstStyle/>
-          <a:p>
-            <a:pPr indent="0" marL="0">
-              <a:buNone/>
-            </a:pPr>
-            <a:r>
-              <a:rPr lang="en-US" sz="1450" b="1" dirty="0">
-                <a:solidFill>
-                  <a:schemeClr val="tx1"/>
-                </a:solidFill>
-              </a:rPr>
-              <a:t>Outside the list</a:t>
-            </a:r>
-            <a:endParaRPr lang="en-US" sz="1400" dirty="0"/>
-          </a:p>
-          <a:p>
-            <a:pPr indent="0" marL="0">
-              <a:buNone/>
-            </a:pPr>
-            <a:r>
-              <a:rPr lang="en-US" sz="1200" dirty="0">
-                <a:solidFill>
-                  <a:schemeClr val="tx1"/>
-                </a:solidFill>
-              </a:rPr>
-              <a:t>A new action or segment the AI suggests goes to For Review, tagged, for a person to approve.</a:t>
-            </a:r>
-            <a:endParaRPr lang="en-US" sz="1400" dirty="0"/>
+              <a:rPr lang="en-US" sz="1250" dirty="0">
+                <a:solidFill>
+                  <a:schemeClr val="tx2"/>
+                </a:solidFill>
+              </a:rPr>
+              <a:t>your team sets the actions in Setup, the AI picks the one that fits the signal and person, and anything outside the list goes to For Review, tagged.</a:t>
+            </a:r>
+            <a:endParaRPr lang="en-US" sz="1250" dirty="0"/>
           </a:p>
         </p:txBody>
       </p:sp>
@@ -16060,12 +16085,12 @@
         </p:nvSpPr>
         <p:spPr>
           <a:xfrm>
-            <a:off x="548640" y="1371600"/>
-            <a:ext cx="5394960" cy="4434840"/>
+            <a:off x="548640" y="1325880"/>
+            <a:ext cx="5394960" cy="4206240"/>
           </a:xfrm>
           <a:prstGeom prst="roundRect">
             <a:avLst>
-              <a:gd name="adj" fmla="val 1649"/>
+              <a:gd name="adj" fmla="val 1739"/>
             </a:avLst>
           </a:prstGeom>
           <a:solidFill>
@@ -16087,8 +16112,8 @@
         </p:nvSpPr>
         <p:spPr>
           <a:xfrm>
-            <a:off x="822960" y="1508760"/>
-            <a:ext cx="1463040" cy="914400"/>
+            <a:off x="822960" y="1417320"/>
+            <a:ext cx="1280160" cy="822960"/>
           </a:xfrm>
           <a:prstGeom prst="rect">
             <a:avLst/>
@@ -16097,21 +16122,21 @@
           <a:ln/>
         </p:spPr>
         <p:txBody>
-          <a:bodyPr wrap="square" lIns="0" tIns="0" rIns="0" bIns="0" rtlCol="0" anchor="t"/>
+          <a:bodyPr wrap="square" lIns="0" tIns="0" rIns="0" bIns="0" rtlCol="0" anchor="ctr"/>
           <a:lstStyle/>
           <a:p>
             <a:pPr indent="0" marL="0">
               <a:buNone/>
             </a:pPr>
             <a:r>
-              <a:rPr lang="en-US" sz="5400" b="1" dirty="0">
+              <a:rPr lang="en-US" sz="4800" b="1" dirty="0">
                 <a:solidFill>
                   <a:schemeClr val="accent1"/>
                 </a:solidFill>
               </a:rPr>
               <a:t>G1</a:t>
             </a:r>
-            <a:endParaRPr lang="en-US" sz="5400" dirty="0"/>
+            <a:endParaRPr lang="en-US" sz="4800" dirty="0"/>
           </a:p>
         </p:txBody>
       </p:sp>
@@ -16123,8 +16148,8 @@
         </p:nvSpPr>
         <p:spPr>
           <a:xfrm>
-            <a:off x="2286000" y="1554480"/>
-            <a:ext cx="3474720" cy="1005840"/>
+            <a:off x="2103120" y="1417320"/>
+            <a:ext cx="3657600" cy="822960"/>
           </a:xfrm>
           <a:prstGeom prst="rect">
             <a:avLst/>
@@ -16140,7 +16165,7 @@
               <a:buNone/>
             </a:pPr>
             <a:r>
-              <a:rPr lang="en-US" sz="2200" b="1" dirty="0">
+              <a:rPr lang="en-US" sz="2100" b="1" dirty="0">
                 <a:solidFill>
                   <a:schemeClr val="bg1"/>
                 </a:solidFill>
@@ -16154,12 +16179,12 @@
               <a:buNone/>
             </a:pPr>
             <a:r>
-              <a:rPr lang="en-US" sz="1300" i="1" dirty="0">
+              <a:rPr lang="en-US" sz="1250" i="1" dirty="0">
                 <a:solidFill>
                   <a:schemeClr val="bg1"/>
                 </a:solidFill>
               </a:rPr>
-              <a:t>How much time does a person spend making each first action usable?</a:t>
+              <a:t>Does DemandAI save people time?</a:t>
             </a:r>
             <a:endParaRPr lang="en-US" sz="1400" dirty="0"/>
           </a:p>
@@ -16167,18 +16192,54 @@
       </p:sp>
       <p:sp>
         <p:nvSpPr>
-          <p:cNvPr id="7" name="Shape 5"/>
+          <p:cNvPr id="7" name="Text 5"/>
+          <p:cNvSpPr txBox="1"/>
+          <p:nvPr/>
+        </p:nvSpPr>
+        <p:spPr>
+          <a:xfrm>
+            <a:off x="822960" y="2377440"/>
+            <a:ext cx="2743200" cy="228600"/>
+          </a:xfrm>
+          <a:prstGeom prst="rect">
+            <a:avLst/>
+          </a:prstGeom>
+          <a:noFill/>
+          <a:ln/>
+        </p:spPr>
+        <p:txBody>
+          <a:bodyPr wrap="square" lIns="0" tIns="0" rIns="0" bIns="0" rtlCol="0" anchor="t"/>
+          <a:lstStyle/>
+          <a:p>
+            <a:pPr indent="0" marL="0">
+              <a:buNone/>
+            </a:pPr>
+            <a:r>
+              <a:rPr lang="en-US" sz="1050" b="1" spc="100" kern="0" dirty="0">
+                <a:solidFill>
+                  <a:schemeClr val="accent1"/>
+                </a:solidFill>
+              </a:rPr>
+              <a:t>THE FORMULA</a:t>
+            </a:r>
+            <a:endParaRPr lang="en-US" sz="1050" dirty="0"/>
+          </a:p>
+        </p:txBody>
+      </p:sp>
+      <p:sp>
+        <p:nvSpPr>
+          <p:cNvPr id="8" name="Shape 6"/>
           <p:cNvSpPr/>
           <p:nvPr/>
         </p:nvSpPr>
         <p:spPr>
           <a:xfrm>
-            <a:off x="822960" y="2743200"/>
-            <a:ext cx="4846320" cy="566928"/>
+            <a:off x="822960" y="2633472"/>
+            <a:ext cx="4846320" cy="960120"/>
           </a:xfrm>
           <a:prstGeom prst="roundRect">
             <a:avLst>
-              <a:gd name="adj" fmla="val 12903"/>
+              <a:gd name="adj" fmla="val 7619"/>
             </a:avLst>
           </a:prstGeom>
           <a:solidFill>
@@ -16194,14 +16255,14 @@
       </p:sp>
       <p:sp>
         <p:nvSpPr>
-          <p:cNvPr id="8" name="Text 6"/>
+          <p:cNvPr id="9" name="Text 7"/>
           <p:cNvSpPr txBox="1"/>
           <p:nvPr/>
         </p:nvSpPr>
         <p:spPr>
           <a:xfrm>
-            <a:off x="1005840" y="2743200"/>
-            <a:ext cx="4572000" cy="566928"/>
+            <a:off x="960120" y="2633472"/>
+            <a:ext cx="4572000" cy="960120"/>
           </a:xfrm>
           <a:prstGeom prst="rect">
             <a:avLst/>
@@ -16219,235 +16280,184 @@
             <a:r>
               <a:rPr lang="en-US" sz="1300" b="1" dirty="0">
                 <a:solidFill>
+                  <a:schemeClr val="bg1"/>
+                </a:solidFill>
+              </a:rPr>
+              <a:t>Minutes per action = </a:t>
+            </a:r>
+            <a:pPr indent="0" marL="0">
+              <a:buNone/>
+            </a:pPr>
+            <a:r>
+              <a:rPr lang="en-US" sz="1300" dirty="0">
+                <a:solidFill>
+                  <a:schemeClr val="bg1"/>
+                </a:solidFill>
+              </a:rPr>
+              <a:t>minutes people spent deciding in For Review ÷ actions released</a:t>
+            </a:r>
+            <a:endParaRPr lang="en-US" sz="1300" dirty="0"/>
+          </a:p>
+          <a:p>
+            <a:pPr indent="0" marL="0">
+              <a:buNone/>
+            </a:pPr>
+            <a:r>
+              <a:rPr lang="en-US" sz="1300" b="1" dirty="0">
+                <a:solidFill>
+                  <a:schemeClr val="bg1"/>
+                </a:solidFill>
+              </a:rPr>
+              <a:t>Effort saved = </a:t>
+            </a:r>
+            <a:pPr indent="0" marL="0">
+              <a:buNone/>
+            </a:pPr>
+            <a:r>
+              <a:rPr lang="en-US" sz="1300" dirty="0">
+                <a:solidFill>
+                  <a:schemeClr val="bg1"/>
+                </a:solidFill>
+              </a:rPr>
+              <a:t>1 − (minutes per action ÷ baseline)</a:t>
+            </a:r>
+            <a:endParaRPr lang="en-US" sz="1300" dirty="0"/>
+          </a:p>
+        </p:txBody>
+      </p:sp>
+      <p:sp>
+        <p:nvSpPr>
+          <p:cNvPr id="10" name="Text 8"/>
+          <p:cNvSpPr txBox="1"/>
+          <p:nvPr/>
+        </p:nvSpPr>
+        <p:spPr>
+          <a:xfrm>
+            <a:off x="822960" y="3703320"/>
+            <a:ext cx="2743200" cy="228600"/>
+          </a:xfrm>
+          <a:prstGeom prst="rect">
+            <a:avLst/>
+          </a:prstGeom>
+          <a:noFill/>
+          <a:ln/>
+        </p:spPr>
+        <p:txBody>
+          <a:bodyPr wrap="square" lIns="0" tIns="0" rIns="0" bIns="0" rtlCol="0" anchor="t"/>
+          <a:lstStyle/>
+          <a:p>
+            <a:pPr indent="0" marL="0">
+              <a:buNone/>
+            </a:pPr>
+            <a:r>
+              <a:rPr lang="en-US" sz="1050" b="1" spc="100" kern="0" dirty="0">
+                <a:solidFill>
                   <a:schemeClr val="accent1"/>
                 </a:solidFill>
               </a:rPr>
-              <a:t>Measured as   </a:t>
-            </a:r>
+              <a:t>WORKED EXAMPLE</a:t>
+            </a:r>
+            <a:endParaRPr lang="en-US" sz="1050" dirty="0"/>
+          </a:p>
+        </p:txBody>
+      </p:sp>
+      <p:sp>
+        <p:nvSpPr>
+          <p:cNvPr id="11" name="Text 9"/>
+          <p:cNvSpPr txBox="1"/>
+          <p:nvPr/>
+        </p:nvSpPr>
+        <p:spPr>
+          <a:xfrm>
+            <a:off x="822960" y="3950208"/>
+            <a:ext cx="4846320" cy="960120"/>
+          </a:xfrm>
+          <a:prstGeom prst="rect">
+            <a:avLst/>
+          </a:prstGeom>
+          <a:noFill/>
+          <a:ln/>
+        </p:spPr>
+        <p:txBody>
+          <a:bodyPr wrap="square" lIns="0" tIns="0" rIns="0" bIns="0" rtlCol="0" anchor="t"/>
+          <a:lstStyle/>
+          <a:p>
             <a:pPr indent="0" marL="0">
               <a:buNone/>
             </a:pPr>
             <a:r>
-              <a:rPr lang="en-US" sz="1300" dirty="0">
+              <a:rPr lang="en-US" sz="1250" dirty="0">
                 <a:solidFill>
                   <a:schemeClr val="bg1"/>
                 </a:solidFill>
               </a:rPr>
-              <a:t>Review minutes per usable first action, from For Review timings</a:t>
-            </a:r>
-            <a:endParaRPr lang="en-US" sz="1300" dirty="0"/>
-          </a:p>
-        </p:txBody>
-      </p:sp>
-      <p:sp>
-        <p:nvSpPr>
-          <p:cNvPr id="9" name="Shape 7"/>
+              <a:t>20 actions released; people spent 150 minutes reviewing in total. 150 ÷ 20 = 7.5 minutes per action. Today it takes 38 minutes, so 1 − 7.5 ÷ 38 = 80% less effort.</a:t>
+            </a:r>
+            <a:endParaRPr lang="en-US" sz="1250" dirty="0"/>
+          </a:p>
+        </p:txBody>
+      </p:sp>
+      <p:sp>
+        <p:nvSpPr>
+          <p:cNvPr id="12" name="Text 10"/>
+          <p:cNvSpPr txBox="1"/>
+          <p:nvPr/>
+        </p:nvSpPr>
+        <p:spPr>
+          <a:xfrm>
+            <a:off x="822960" y="4983480"/>
+            <a:ext cx="4846320" cy="411480"/>
+          </a:xfrm>
+          <a:prstGeom prst="rect">
+            <a:avLst/>
+          </a:prstGeom>
+          <a:noFill/>
+          <a:ln/>
+        </p:spPr>
+        <p:txBody>
+          <a:bodyPr wrap="square" lIns="0" tIns="0" rIns="0" bIns="0" rtlCol="0" anchor="ctr"/>
+          <a:lstStyle/>
+          <a:p>
+            <a:pPr indent="0" marL="0">
+              <a:buNone/>
+            </a:pPr>
+            <a:r>
+              <a:rPr lang="en-US" sz="1500" b="1" dirty="0">
+                <a:solidFill>
+                  <a:schemeClr val="accent1"/>
+                </a:solidFill>
+              </a:rPr>
+              <a:t>Passes when  </a:t>
+            </a:r>
+            <a:pPr indent="0" marL="0">
+              <a:buNone/>
+            </a:pPr>
+            <a:r>
+              <a:rPr lang="en-US" sz="1500" b="1" dirty="0">
+                <a:solidFill>
+                  <a:schemeClr val="bg1"/>
+                </a:solidFill>
+              </a:rPr>
+              <a:t>effort is at least 50% lower than the baseline</a:t>
+            </a:r>
+            <a:endParaRPr lang="en-US" sz="1500" dirty="0"/>
+          </a:p>
+        </p:txBody>
+      </p:sp>
+      <p:sp>
+        <p:nvSpPr>
+          <p:cNvPr id="13" name="Shape 11"/>
           <p:cNvSpPr/>
           <p:nvPr/>
         </p:nvSpPr>
         <p:spPr>
           <a:xfrm>
-            <a:off x="822960" y="3401568"/>
-            <a:ext cx="4846320" cy="566928"/>
+            <a:off x="6172200" y="1325880"/>
+            <a:ext cx="5394960" cy="4206240"/>
           </a:xfrm>
           <a:prstGeom prst="roundRect">
             <a:avLst>
-              <a:gd name="adj" fmla="val 12903"/>
-            </a:avLst>
-          </a:prstGeom>
-          <a:solidFill>
-            <a:schemeClr val="tx2"/>
-          </a:solidFill>
-          <a:ln w="12700">
-            <a:solidFill>
-              <a:schemeClr val="tx2"/>
-            </a:solidFill>
-            <a:prstDash val="solid"/>
-          </a:ln>
-        </p:spPr>
-      </p:sp>
-      <p:sp>
-        <p:nvSpPr>
-          <p:cNvPr id="10" name="Text 8"/>
-          <p:cNvSpPr txBox="1"/>
-          <p:nvPr/>
-        </p:nvSpPr>
-        <p:spPr>
-          <a:xfrm>
-            <a:off x="1005840" y="3401568"/>
-            <a:ext cx="4572000" cy="566928"/>
-          </a:xfrm>
-          <a:prstGeom prst="rect">
-            <a:avLst/>
-          </a:prstGeom>
-          <a:noFill/>
-          <a:ln/>
-        </p:spPr>
-        <p:txBody>
-          <a:bodyPr wrap="square" lIns="0" tIns="0" rIns="0" bIns="0" rtlCol="0" anchor="ctr"/>
-          <a:lstStyle/>
-          <a:p>
-            <a:pPr indent="0" marL="0">
-              <a:buNone/>
-            </a:pPr>
-            <a:r>
-              <a:rPr lang="en-US" sz="1300" b="1" dirty="0">
-                <a:solidFill>
-                  <a:schemeClr val="accent1"/>
-                </a:solidFill>
-              </a:rPr>
-              <a:t>Compared with   </a:t>
-            </a:r>
-            <a:pPr indent="0" marL="0">
-              <a:buNone/>
-            </a:pPr>
-            <a:r>
-              <a:rPr lang="en-US" sz="1300" dirty="0">
-                <a:solidFill>
-                  <a:schemeClr val="bg1"/>
-                </a:solidFill>
-              </a:rPr>
-              <a:t>Your timed baseline (placeholder: 38 minutes today)</a:t>
-            </a:r>
-            <a:endParaRPr lang="en-US" sz="1300" dirty="0"/>
-          </a:p>
-        </p:txBody>
-      </p:sp>
-      <p:sp>
-        <p:nvSpPr>
-          <p:cNvPr id="11" name="Shape 9"/>
-          <p:cNvSpPr/>
-          <p:nvPr/>
-        </p:nvSpPr>
-        <p:spPr>
-          <a:xfrm>
-            <a:off x="822960" y="4059936"/>
-            <a:ext cx="4846320" cy="566928"/>
-          </a:xfrm>
-          <a:prstGeom prst="roundRect">
-            <a:avLst>
-              <a:gd name="adj" fmla="val 12903"/>
-            </a:avLst>
-          </a:prstGeom>
-          <a:solidFill>
-            <a:schemeClr val="tx2"/>
-          </a:solidFill>
-          <a:ln w="12700">
-            <a:solidFill>
-              <a:schemeClr val="tx2"/>
-            </a:solidFill>
-            <a:prstDash val="solid"/>
-          </a:ln>
-        </p:spPr>
-      </p:sp>
-      <p:sp>
-        <p:nvSpPr>
-          <p:cNvPr id="12" name="Text 10"/>
-          <p:cNvSpPr txBox="1"/>
-          <p:nvPr/>
-        </p:nvSpPr>
-        <p:spPr>
-          <a:xfrm>
-            <a:off x="1005840" y="4059936"/>
-            <a:ext cx="4572000" cy="566928"/>
-          </a:xfrm>
-          <a:prstGeom prst="rect">
-            <a:avLst/>
-          </a:prstGeom>
-          <a:noFill/>
-          <a:ln/>
-        </p:spPr>
-        <p:txBody>
-          <a:bodyPr wrap="square" lIns="0" tIns="0" rIns="0" bIns="0" rtlCol="0" anchor="ctr"/>
-          <a:lstStyle/>
-          <a:p>
-            <a:pPr indent="0" marL="0">
-              <a:buNone/>
-            </a:pPr>
-            <a:r>
-              <a:rPr lang="en-US" sz="1300" b="1" dirty="0">
-                <a:solidFill>
-                  <a:schemeClr val="accent1"/>
-                </a:solidFill>
-              </a:rPr>
-              <a:t>Passes when   </a:t>
-            </a:r>
-            <a:pPr indent="0" marL="0">
-              <a:buNone/>
-            </a:pPr>
-            <a:r>
-              <a:rPr lang="en-US" sz="1300" dirty="0">
-                <a:solidFill>
-                  <a:schemeClr val="bg1"/>
-                </a:solidFill>
-              </a:rPr>
-              <a:t>Effort drops by at least 50%</a:t>
-            </a:r>
-            <a:endParaRPr lang="en-US" sz="1300" dirty="0"/>
-          </a:p>
-        </p:txBody>
-      </p:sp>
-      <p:sp>
-        <p:nvSpPr>
-          <p:cNvPr id="13" name="Text 11"/>
-          <p:cNvSpPr txBox="1"/>
-          <p:nvPr/>
-        </p:nvSpPr>
-        <p:spPr>
-          <a:xfrm>
-            <a:off x="822960" y="4846320"/>
-            <a:ext cx="4846320" cy="457200"/>
-          </a:xfrm>
-          <a:prstGeom prst="rect">
-            <a:avLst/>
-          </a:prstGeom>
-          <a:noFill/>
-          <a:ln/>
-        </p:spPr>
-        <p:txBody>
-          <a:bodyPr wrap="square" lIns="0" tIns="0" rIns="0" bIns="0" rtlCol="0" anchor="ctr"/>
-          <a:lstStyle/>
-          <a:p>
-            <a:pPr indent="0" marL="0">
-              <a:buNone/>
-            </a:pPr>
-            <a:r>
-              <a:rPr lang="en-US" sz="1500" b="1" dirty="0">
-                <a:solidFill>
-                  <a:schemeClr val="accent1"/>
-                </a:solidFill>
-              </a:rPr>
-              <a:t>Example  </a:t>
-            </a:r>
-            <a:pPr indent="0" marL="0">
-              <a:buNone/>
-            </a:pPr>
-            <a:r>
-              <a:rPr lang="en-US" sz="1500" b="1" dirty="0">
-                <a:solidFill>
-                  <a:schemeClr val="bg1"/>
-                </a:solidFill>
-              </a:rPr>
-              <a:t>38 min → 19 min or less</a:t>
-            </a:r>
-            <a:endParaRPr lang="en-US" sz="1500" dirty="0"/>
-          </a:p>
-        </p:txBody>
-      </p:sp>
-      <p:sp>
-        <p:nvSpPr>
-          <p:cNvPr id="14" name="Shape 12"/>
-          <p:cNvSpPr/>
-          <p:nvPr/>
-        </p:nvSpPr>
-        <p:spPr>
-          <a:xfrm>
-            <a:off x="6172200" y="1371600"/>
-            <a:ext cx="5394960" cy="4434840"/>
-          </a:xfrm>
-          <a:prstGeom prst="roundRect">
-            <a:avLst>
-              <a:gd name="adj" fmla="val 1649"/>
+              <a:gd name="adj" fmla="val 1739"/>
             </a:avLst>
           </a:prstGeom>
           <a:solidFill>
@@ -16463,14 +16473,50 @@
       </p:sp>
       <p:sp>
         <p:nvSpPr>
+          <p:cNvPr id="14" name="Text 12"/>
+          <p:cNvSpPr txBox="1"/>
+          <p:nvPr/>
+        </p:nvSpPr>
+        <p:spPr>
+          <a:xfrm>
+            <a:off x="6446520" y="1417320"/>
+            <a:ext cx="1280160" cy="822960"/>
+          </a:xfrm>
+          <a:prstGeom prst="rect">
+            <a:avLst/>
+          </a:prstGeom>
+          <a:noFill/>
+          <a:ln/>
+        </p:spPr>
+        <p:txBody>
+          <a:bodyPr wrap="square" lIns="0" tIns="0" rIns="0" bIns="0" rtlCol="0" anchor="ctr"/>
+          <a:lstStyle/>
+          <a:p>
+            <a:pPr indent="0" marL="0">
+              <a:buNone/>
+            </a:pPr>
+            <a:r>
+              <a:rPr lang="en-US" sz="4800" b="1" dirty="0">
+                <a:solidFill>
+                  <a:schemeClr val="accent1"/>
+                </a:solidFill>
+              </a:rPr>
+              <a:t>G2</a:t>
+            </a:r>
+            <a:endParaRPr lang="en-US" sz="4800" dirty="0"/>
+          </a:p>
+        </p:txBody>
+      </p:sp>
+      <p:sp>
+        <p:nvSpPr>
           <p:cNvPr id="15" name="Text 13"/>
           <p:cNvSpPr txBox="1"/>
           <p:nvPr/>
         </p:nvSpPr>
         <p:spPr>
           <a:xfrm>
-            <a:off x="6446520" y="1508760"/>
-            <a:ext cx="1463040" cy="914400"/>
+            <a:off x="7726680" y="1417320"/>
+            <a:ext cx="3657600" cy="822960"/>
           </a:xfrm>
           <a:prstGeom prst="rect">
             <a:avLst/>
@@ -16479,21 +16525,35 @@
           <a:ln/>
         </p:spPr>
         <p:txBody>
-          <a:bodyPr wrap="square" lIns="0" tIns="0" rIns="0" bIns="0" rtlCol="0" anchor="t"/>
+          <a:bodyPr wrap="square" lIns="0" tIns="0" rIns="0" bIns="0" rtlCol="0" anchor="ctr"/>
           <a:lstStyle/>
           <a:p>
             <a:pPr indent="0" marL="0">
               <a:buNone/>
             </a:pPr>
             <a:r>
-              <a:rPr lang="en-US" sz="5400" b="1" dirty="0">
-                <a:solidFill>
-                  <a:schemeClr val="accent1"/>
-                </a:solidFill>
-              </a:rPr>
-              <a:t>G2</a:t>
-            </a:r>
-            <a:endParaRPr lang="en-US" sz="5400" dirty="0"/>
+              <a:rPr lang="en-US" sz="2100" b="1" dirty="0">
+                <a:solidFill>
+                  <a:schemeClr val="tx1"/>
+                </a:solidFill>
+              </a:rPr>
+              <a:t>Acceptance rate</a:t>
+            </a:r>
+            <a:endParaRPr lang="en-US" sz="1400" dirty="0"/>
+          </a:p>
+          <a:p>
+            <a:pPr indent="0" marL="0">
+              <a:buNone/>
+            </a:pPr>
+            <a:r>
+              <a:rPr lang="en-US" sz="1250" i="1" dirty="0">
+                <a:solidFill>
+                  <a:schemeClr val="tx1"/>
+                </a:solidFill>
+              </a:rPr>
+              <a:t>Do people trust what it recommends?</a:t>
+            </a:r>
+            <a:endParaRPr lang="en-US" sz="1400" dirty="0"/>
           </a:p>
         </p:txBody>
       </p:sp>
@@ -16505,8 +16565,8 @@
         </p:nvSpPr>
         <p:spPr>
           <a:xfrm>
-            <a:off x="7909560" y="1554480"/>
-            <a:ext cx="3474720" cy="1005840"/>
+            <a:off x="6446520" y="2377440"/>
+            <a:ext cx="2743200" cy="228600"/>
           </a:xfrm>
           <a:prstGeom prst="rect">
             <a:avLst/>
@@ -16515,35 +16575,21 @@
           <a:ln/>
         </p:spPr>
         <p:txBody>
-          <a:bodyPr wrap="square" lIns="0" tIns="0" rIns="0" bIns="0" rtlCol="0" anchor="ctr"/>
+          <a:bodyPr wrap="square" lIns="0" tIns="0" rIns="0" bIns="0" rtlCol="0" anchor="t"/>
           <a:lstStyle/>
           <a:p>
             <a:pPr indent="0" marL="0">
               <a:buNone/>
             </a:pPr>
             <a:r>
-              <a:rPr lang="en-US" sz="2200" b="1" dirty="0">
-                <a:solidFill>
-                  <a:schemeClr val="tx1"/>
-                </a:solidFill>
-              </a:rPr>
-              <a:t>Acceptance rate</a:t>
-            </a:r>
-            <a:endParaRPr lang="en-US" sz="1400" dirty="0"/>
-          </a:p>
-          <a:p>
-            <a:pPr indent="0" marL="0">
-              <a:buNone/>
-            </a:pPr>
-            <a:r>
-              <a:rPr lang="en-US" sz="1300" i="1" dirty="0">
-                <a:solidFill>
-                  <a:schemeClr val="tx1"/>
-                </a:solidFill>
-              </a:rPr>
-              <a:t>How often does a person accept the recommended action on the first pass?</a:t>
-            </a:r>
-            <a:endParaRPr lang="en-US" sz="1400" dirty="0"/>
+              <a:rPr lang="en-US" sz="1050" b="1" spc="100" kern="0" dirty="0">
+                <a:solidFill>
+                  <a:schemeClr val="accent3"/>
+                </a:solidFill>
+              </a:rPr>
+              <a:t>THE FORMULA</a:t>
+            </a:r>
+            <a:endParaRPr lang="en-US" sz="1050" dirty="0"/>
           </a:p>
         </p:txBody>
       </p:sp>
@@ -16555,12 +16601,12 @@
         </p:nvSpPr>
         <p:spPr>
           <a:xfrm>
-            <a:off x="6446520" y="2743200"/>
-            <a:ext cx="4846320" cy="566928"/>
+            <a:off x="6446520" y="2633472"/>
+            <a:ext cx="4846320" cy="960120"/>
           </a:xfrm>
           <a:prstGeom prst="roundRect">
             <a:avLst>
-              <a:gd name="adj" fmla="val 12903"/>
+              <a:gd name="adj" fmla="val 7619"/>
             </a:avLst>
           </a:prstGeom>
           <a:solidFill>
@@ -16582,8 +16628,8 @@
         </p:nvSpPr>
         <p:spPr>
           <a:xfrm>
-            <a:off x="6629400" y="2743200"/>
-            <a:ext cx="4572000" cy="566928"/>
+            <a:off x="6583680" y="2633472"/>
+            <a:ext cx="4572000" cy="960120"/>
           </a:xfrm>
           <a:prstGeom prst="rect">
             <a:avLst/>
@@ -16601,48 +16647,192 @@
             <a:r>
               <a:rPr lang="en-US" sz="1300" b="1" dirty="0">
                 <a:solidFill>
+                  <a:schemeClr val="tx1"/>
+                </a:solidFill>
+              </a:rPr>
+              <a:t>Acceptance = </a:t>
+            </a:r>
+            <a:pPr indent="0" marL="0">
+              <a:buNone/>
+            </a:pPr>
+            <a:r>
+              <a:rPr lang="en-US" sz="1300" dirty="0">
+                <a:solidFill>
+                  <a:schemeClr val="tx1"/>
+                </a:solidFill>
+              </a:rPr>
+              <a:t>recommendations accepted on the first look ÷ recommendations decided</a:t>
+            </a:r>
+            <a:endParaRPr lang="en-US" sz="1300" dirty="0"/>
+          </a:p>
+          <a:p>
+            <a:pPr indent="0" marL="0">
+              <a:buNone/>
+            </a:pPr>
+            <a:r>
+              <a:rPr lang="en-US" sz="1300" b="1" dirty="0">
+                <a:solidFill>
+                  <a:schemeClr val="tx1"/>
+                </a:solidFill>
+              </a:rPr>
+              <a:t>Counted from: </a:t>
+            </a:r>
+            <a:pPr indent="0" marL="0">
+              <a:buNone/>
+            </a:pPr>
+            <a:r>
+              <a:rPr lang="en-US" sz="1300" dirty="0">
+                <a:solidFill>
+                  <a:schemeClr val="tx1"/>
+                </a:solidFill>
+              </a:rPr>
+              <a:t>the exception queue and the weekly spot-check, weighted by how many items took each path</a:t>
+            </a:r>
+            <a:endParaRPr lang="en-US" sz="1300" dirty="0"/>
+          </a:p>
+        </p:txBody>
+      </p:sp>
+      <p:sp>
+        <p:nvSpPr>
+          <p:cNvPr id="19" name="Text 17"/>
+          <p:cNvSpPr txBox="1"/>
+          <p:nvPr/>
+        </p:nvSpPr>
+        <p:spPr>
+          <a:xfrm>
+            <a:off x="6446520" y="3703320"/>
+            <a:ext cx="2743200" cy="228600"/>
+          </a:xfrm>
+          <a:prstGeom prst="rect">
+            <a:avLst/>
+          </a:prstGeom>
+          <a:noFill/>
+          <a:ln/>
+        </p:spPr>
+        <p:txBody>
+          <a:bodyPr wrap="square" lIns="0" tIns="0" rIns="0" bIns="0" rtlCol="0" anchor="t"/>
+          <a:lstStyle/>
+          <a:p>
+            <a:pPr indent="0" marL="0">
+              <a:buNone/>
+            </a:pPr>
+            <a:r>
+              <a:rPr lang="en-US" sz="1050" b="1" spc="100" kern="0" dirty="0">
+                <a:solidFill>
                   <a:schemeClr val="accent3"/>
                 </a:solidFill>
               </a:rPr>
-              <a:t>Measured as   </a:t>
-            </a:r>
+              <a:t>WORKED EXAMPLE</a:t>
+            </a:r>
+            <a:endParaRPr lang="en-US" sz="1050" dirty="0"/>
+          </a:p>
+        </p:txBody>
+      </p:sp>
+      <p:sp>
+        <p:nvSpPr>
+          <p:cNvPr id="20" name="Text 18"/>
+          <p:cNvSpPr txBox="1"/>
+          <p:nvPr/>
+        </p:nvSpPr>
+        <p:spPr>
+          <a:xfrm>
+            <a:off x="6446520" y="3950208"/>
+            <a:ext cx="4846320" cy="960120"/>
+          </a:xfrm>
+          <a:prstGeom prst="rect">
+            <a:avLst/>
+          </a:prstGeom>
+          <a:noFill/>
+          <a:ln/>
+        </p:spPr>
+        <p:txBody>
+          <a:bodyPr wrap="square" lIns="0" tIns="0" rIns="0" bIns="0" rtlCol="0" anchor="t"/>
+          <a:lstStyle/>
+          <a:p>
             <a:pPr indent="0" marL="0">
               <a:buNone/>
             </a:pPr>
             <a:r>
-              <a:rPr lang="en-US" sz="1300" dirty="0">
+              <a:rPr lang="en-US" sz="1250" dirty="0">
                 <a:solidFill>
                   <a:schemeClr val="tx1"/>
                 </a:solidFill>
               </a:rPr>
-              <a:t>Accepted ÷ decided, first-pass and exception items</a:t>
-            </a:r>
-            <a:endParaRPr lang="en-US" sz="1300" dirty="0"/>
-          </a:p>
-        </p:txBody>
-      </p:sp>
-      <p:sp>
-        <p:nvSpPr>
-          <p:cNvPr id="19" name="Shape 17"/>
+              <a:t>Spot-check: 8 of 10 accepted (80%), on the 60% of items that went ahead. Queue: 5 of 10 accepted (50%), on the other 40%. 80% × 0.6 + 50% × 0.4 = 68%.</a:t>
+            </a:r>
+            <a:endParaRPr lang="en-US" sz="1250" dirty="0"/>
+          </a:p>
+        </p:txBody>
+      </p:sp>
+      <p:sp>
+        <p:nvSpPr>
+          <p:cNvPr id="21" name="Text 19"/>
+          <p:cNvSpPr txBox="1"/>
+          <p:nvPr/>
+        </p:nvSpPr>
+        <p:spPr>
+          <a:xfrm>
+            <a:off x="6446520" y="4983480"/>
+            <a:ext cx="4846320" cy="411480"/>
+          </a:xfrm>
+          <a:prstGeom prst="rect">
+            <a:avLst/>
+          </a:prstGeom>
+          <a:noFill/>
+          <a:ln/>
+        </p:spPr>
+        <p:txBody>
+          <a:bodyPr wrap="square" lIns="0" tIns="0" rIns="0" bIns="0" rtlCol="0" anchor="ctr"/>
+          <a:lstStyle/>
+          <a:p>
+            <a:pPr indent="0" marL="0">
+              <a:buNone/>
+            </a:pPr>
+            <a:r>
+              <a:rPr lang="en-US" sz="1500" b="1" dirty="0">
+                <a:solidFill>
+                  <a:schemeClr val="accent3"/>
+                </a:solidFill>
+              </a:rPr>
+              <a:t>Passes when  </a:t>
+            </a:r>
+            <a:pPr indent="0" marL="0">
+              <a:buNone/>
+            </a:pPr>
+            <a:r>
+              <a:rPr lang="en-US" sz="1500" b="1" dirty="0">
+                <a:solidFill>
+                  <a:schemeClr val="tx1"/>
+                </a:solidFill>
+              </a:rPr>
+              <a:t>at least 70% are accepted (68% falls just short)</a:t>
+            </a:r>
+            <a:endParaRPr lang="en-US" sz="1500" dirty="0"/>
+          </a:p>
+        </p:txBody>
+      </p:sp>
+      <p:sp>
+        <p:nvSpPr>
+          <p:cNvPr id="22" name="Shape 20"/>
           <p:cNvSpPr/>
           <p:nvPr/>
         </p:nvSpPr>
         <p:spPr>
           <a:xfrm>
-            <a:off x="6446520" y="3401568"/>
-            <a:ext cx="4846320" cy="566928"/>
+            <a:off x="548640" y="5669280"/>
+            <a:ext cx="11094415" cy="640080"/>
           </a:xfrm>
           <a:prstGeom prst="roundRect">
             <a:avLst>
-              <a:gd name="adj" fmla="val 12903"/>
+              <a:gd name="adj" fmla="val 11429"/>
             </a:avLst>
           </a:prstGeom>
           <a:solidFill>
-            <a:schemeClr val="bg1"/>
+            <a:schemeClr val="bg2"/>
           </a:solidFill>
           <a:ln w="12700">
             <a:solidFill>
-              <a:schemeClr val="bg1"/>
+              <a:schemeClr val="bg2"/>
             </a:solidFill>
             <a:prstDash val="solid"/>
           </a:ln>
@@ -16650,14 +16840,14 @@
       </p:sp>
       <p:sp>
         <p:nvSpPr>
-          <p:cNvPr id="20" name="Text 18"/>
+          <p:cNvPr id="23" name="Text 21"/>
           <p:cNvSpPr txBox="1"/>
           <p:nvPr/>
         </p:nvSpPr>
         <p:spPr>
           <a:xfrm>
-            <a:off x="6629400" y="3401568"/>
-            <a:ext cx="4572000" cy="566928"/>
+            <a:off x="777240" y="5669280"/>
+            <a:ext cx="10637215" cy="640080"/>
           </a:xfrm>
           <a:prstGeom prst="rect">
             <a:avLst/>
@@ -16673,182 +16863,25 @@
               <a:buNone/>
             </a:pPr>
             <a:r>
-              <a:rPr lang="en-US" sz="1300" b="1" dirty="0">
-                <a:solidFill>
-                  <a:schemeClr val="accent3"/>
-                </a:solidFill>
-              </a:rPr>
-              <a:t>Counts as accepted   </a:t>
+              <a:rPr lang="en-US" sz="1250" b="1" dirty="0">
+                <a:solidFill>
+                  <a:schemeClr val="tx1"/>
+                </a:solidFill>
+              </a:rPr>
+              <a:t>Too early to call: </a:t>
             </a:r>
             <a:pPr indent="0" marL="0">
               <a:buNone/>
             </a:pPr>
             <a:r>
-              <a:rPr lang="en-US" sz="1300" dirty="0">
+              <a:rPr lang="en-US" sz="1250" dirty="0">
                 <a:solidFill>
                   <a:schemeClr val="tx1"/>
                 </a:solidFill>
               </a:rPr>
-              <a:t>Accepted as is, or within one alternative</a:t>
-            </a:r>
-            <a:endParaRPr lang="en-US" sz="1300" dirty="0"/>
-          </a:p>
-        </p:txBody>
-      </p:sp>
-      <p:sp>
-        <p:nvSpPr>
-          <p:cNvPr id="21" name="Shape 19"/>
-          <p:cNvSpPr/>
-          <p:nvPr/>
-        </p:nvSpPr>
-        <p:spPr>
-          <a:xfrm>
-            <a:off x="6446520" y="4059936"/>
-            <a:ext cx="4846320" cy="566928"/>
-          </a:xfrm>
-          <a:prstGeom prst="roundRect">
-            <a:avLst>
-              <a:gd name="adj" fmla="val 12903"/>
-            </a:avLst>
-          </a:prstGeom>
-          <a:solidFill>
-            <a:schemeClr val="bg1"/>
-          </a:solidFill>
-          <a:ln w="12700">
-            <a:solidFill>
-              <a:schemeClr val="bg1"/>
-            </a:solidFill>
-            <a:prstDash val="solid"/>
-          </a:ln>
-        </p:spPr>
-      </p:sp>
-      <p:sp>
-        <p:nvSpPr>
-          <p:cNvPr id="22" name="Text 20"/>
-          <p:cNvSpPr txBox="1"/>
-          <p:nvPr/>
-        </p:nvSpPr>
-        <p:spPr>
-          <a:xfrm>
-            <a:off x="6629400" y="4059936"/>
-            <a:ext cx="4572000" cy="566928"/>
-          </a:xfrm>
-          <a:prstGeom prst="rect">
-            <a:avLst/>
-          </a:prstGeom>
-          <a:noFill/>
-          <a:ln/>
-        </p:spPr>
-        <p:txBody>
-          <a:bodyPr wrap="square" lIns="0" tIns="0" rIns="0" bIns="0" rtlCol="0" anchor="ctr"/>
-          <a:lstStyle/>
-          <a:p>
-            <a:pPr indent="0" marL="0">
-              <a:buNone/>
-            </a:pPr>
-            <a:r>
-              <a:rPr lang="en-US" sz="1300" b="1" dirty="0">
-                <a:solidFill>
-                  <a:schemeClr val="accent3"/>
-                </a:solidFill>
-              </a:rPr>
-              <a:t>Passes when   </a:t>
-            </a:r>
-            <a:pPr indent="0" marL="0">
-              <a:buNone/>
-            </a:pPr>
-            <a:r>
-              <a:rPr lang="en-US" sz="1300" dirty="0">
-                <a:solidFill>
-                  <a:schemeClr val="tx1"/>
-                </a:solidFill>
-              </a:rPr>
-              <a:t>At least 70% are accepted</a:t>
-            </a:r>
-            <a:endParaRPr lang="en-US" sz="1300" dirty="0"/>
-          </a:p>
-        </p:txBody>
-      </p:sp>
-      <p:sp>
-        <p:nvSpPr>
-          <p:cNvPr id="23" name="Text 21"/>
-          <p:cNvSpPr txBox="1"/>
-          <p:nvPr/>
-        </p:nvSpPr>
-        <p:spPr>
-          <a:xfrm>
-            <a:off x="6446520" y="4846320"/>
-            <a:ext cx="4846320" cy="457200"/>
-          </a:xfrm>
-          <a:prstGeom prst="rect">
-            <a:avLst/>
-          </a:prstGeom>
-          <a:noFill/>
-          <a:ln/>
-        </p:spPr>
-        <p:txBody>
-          <a:bodyPr wrap="square" lIns="0" tIns="0" rIns="0" bIns="0" rtlCol="0" anchor="ctr"/>
-          <a:lstStyle/>
-          <a:p>
-            <a:pPr indent="0" marL="0">
-              <a:buNone/>
-            </a:pPr>
-            <a:r>
-              <a:rPr lang="en-US" sz="1500" b="1" dirty="0">
-                <a:solidFill>
-                  <a:schemeClr val="accent3"/>
-                </a:solidFill>
-              </a:rPr>
-              <a:t>Example  </a:t>
-            </a:r>
-            <a:pPr indent="0" marL="0">
-              <a:buNone/>
-            </a:pPr>
-            <a:r>
-              <a:rPr lang="en-US" sz="1500" b="1" dirty="0">
-                <a:solidFill>
-                  <a:schemeClr val="tx1"/>
-                </a:solidFill>
-              </a:rPr>
-              <a:t>7 of every 10 or more</a:t>
-            </a:r>
-            <a:endParaRPr lang="en-US" sz="1500" dirty="0"/>
-          </a:p>
-        </p:txBody>
-      </p:sp>
-      <p:sp>
-        <p:nvSpPr>
-          <p:cNvPr id="24" name="Text 22"/>
-          <p:cNvSpPr txBox="1"/>
-          <p:nvPr/>
-        </p:nvSpPr>
-        <p:spPr>
-          <a:xfrm>
-            <a:off x="548640" y="5897880"/>
-            <a:ext cx="11094415" cy="457200"/>
-          </a:xfrm>
-          <a:prstGeom prst="rect">
-            <a:avLst/>
-          </a:prstGeom>
-          <a:noFill/>
-          <a:ln/>
-        </p:spPr>
-        <p:txBody>
-          <a:bodyPr wrap="square" lIns="0" tIns="0" rIns="0" bIns="0" rtlCol="0" anchor="t"/>
-          <a:lstStyle/>
-          <a:p>
-            <a:pPr indent="0" marL="0">
-              <a:buNone/>
-            </a:pPr>
-            <a:r>
-              <a:rPr lang="en-US" sz="1200" dirty="0">
-                <a:solidFill>
-                  <a:schemeClr val="accent4"/>
-                </a:solidFill>
-              </a:rPr>
-              <a:t>Both read "too early to call" until 10 decisions are counted. Baseline, thresholds and the minimum are agreed with you at baselining and can be changed by a manager.</a:t>
-            </a:r>
-            <a:endParaRPr lang="en-US" sz="1200" dirty="0"/>
+              <a:t>neither measure is judged until 10 decisions have been counted (spot-checks plus queue decisions). With 3 decisions, one rejection would swing G2 by 33 points. Baseline (38 min), thresholds and the 10 are agreed with you at baselining.</a:t>
+            </a:r>
+            <a:endParaRPr lang="en-US" sz="1250" dirty="0"/>
           </a:p>
         </p:txBody>
       </p:sp>

</xml_diff>